<commit_message>
v3.3 - skill-compliant rebuild: 18pt+ fonts + speaker notes all decks, SEO schema/OG/canonical/sitemap, WCAG skip-link/focus/contrast 4.5:1, resume page, og-image, custom 404
</commit_message>
<xml_diff>
--- a/decks/agent-operating-model.pptx
+++ b/decks/agent-operating-model.pptx
@@ -207,7 +207,7 @@
                 <a:lstStyle/>
                 <a:p>
                   <a:pPr>
-                    <a:defRPr sz="1000" b="0" i="0" u="none" strike="noStrike">
+                    <a:defRPr sz="1800" b="0" i="0" u="none" strike="noStrike">
                       <a:solidFill>
                         <a:srgbClr val="E2E8F0"/>
                       </a:solidFill>
@@ -232,7 +232,7 @@
                 <a:lstStyle/>
                 <a:p>
                   <a:pPr>
-                    <a:defRPr sz="1000" b="0" i="0" u="none" strike="noStrike">
+                    <a:defRPr sz="1800" b="0" i="0" u="none" strike="noStrike">
                       <a:solidFill>
                         <a:srgbClr val="E2E8F0"/>
                       </a:solidFill>
@@ -257,7 +257,7 @@
                 <a:lstStyle/>
                 <a:p>
                   <a:pPr>
-                    <a:defRPr sz="1000" b="0" i="0" u="none" strike="noStrike">
+                    <a:defRPr sz="1800" b="0" i="0" u="none" strike="noStrike">
                       <a:solidFill>
                         <a:srgbClr val="E2E8F0"/>
                       </a:solidFill>
@@ -282,7 +282,7 @@
                 <a:lstStyle/>
                 <a:p>
                   <a:pPr>
-                    <a:defRPr sz="1000" b="0" i="0" u="none" strike="noStrike">
+                    <a:defRPr sz="1800" b="0" i="0" u="none" strike="noStrike">
                       <a:solidFill>
                         <a:srgbClr val="E2E8F0"/>
                       </a:solidFill>
@@ -363,7 +363,7 @@
           </c:val>
         </c:ser>
         <c:firstSliceAng val="0"/>
-        <c:holeSize val="62"/>
+        <c:holeSize val="60"/>
       </c:doughnutChart>
       <c:spPr>
         <a:solidFill>
@@ -383,7 +383,7 @@
         <a:lstStyle/>
         <a:p>
           <a:pPr>
-            <a:defRPr sz="1100">
+            <a:defRPr sz="1800">
               <a:solidFill>
                 <a:srgbClr val="CBD5E1"/>
               </a:solidFill>
@@ -599,7 +599,7 @@
           <a:lstStyle/>
           <a:p>
             <a:pPr>
-              <a:defRPr sz="1100" b="0" i="0" u="none" strike="noStrike">
+              <a:defRPr sz="1800" b="0" i="0" u="none" strike="noStrike">
                 <a:solidFill>
                   <a:srgbClr val="94A3B8"/>
                 </a:solidFill>
@@ -619,6 +619,7 @@
         <c:axId val="2094734552"/>
         <c:scaling>
           <c:orientation val="minMax"/>
+          <c:min val="0"/>
         </c:scaling>
         <c:delete val="0"/>
         <c:axPos val="l"/>
@@ -651,7 +652,7 @@
           <a:lstStyle/>
           <a:p>
             <a:pPr>
-              <a:defRPr sz="1000" b="0" i="0" u="none" strike="noStrike">
+              <a:defRPr sz="1800" b="0" i="0" u="none" strike="noStrike">
                 <a:solidFill>
                   <a:srgbClr val="94A3B8"/>
                 </a:solidFill>
@@ -964,7 +965,7 @@
           <a:lstStyle/>
           <a:p>
             <a:pPr>
-              <a:defRPr sz="1100" b="0" i="0" u="none" strike="noStrike">
+              <a:defRPr sz="1800" b="0" i="0" u="none" strike="noStrike">
                 <a:solidFill>
                   <a:srgbClr val="94A3B8"/>
                 </a:solidFill>
@@ -984,6 +985,7 @@
         <c:axId val="2094734552"/>
         <c:scaling>
           <c:orientation val="minMax"/>
+          <c:min val="0"/>
         </c:scaling>
         <c:delete val="0"/>
         <c:axPos val="l"/>
@@ -1016,7 +1018,7 @@
           <a:lstStyle/>
           <a:p>
             <a:pPr>
-              <a:defRPr sz="1000" b="0" i="0" u="none" strike="noStrike">
+              <a:defRPr sz="1800" b="0" i="0" u="none" strike="noStrike">
                 <a:solidFill>
                   <a:srgbClr val="94A3B8"/>
                 </a:solidFill>
@@ -1048,7 +1050,7 @@
         <a:lstStyle/>
         <a:p>
           <a:pPr>
-            <a:defRPr sz="1100">
+            <a:defRPr sz="1800">
               <a:solidFill>
                 <a:srgbClr val="CBD5E1"/>
               </a:solidFill>
@@ -1475,7 +1477,7 @@
           <a:p>
             <a:r>
               <a:rPr lang="en-US" dirty="0"/>
-              <a:t/>
+              <a:t>Opening: introduce yourself and this deck, "The 9-Agent Operating Model". | Transition: next up - "What this deck covers".</a:t>
             </a:r>
             <a:endParaRPr lang="en-US" dirty="0"/>
           </a:p>
@@ -1563,7 +1565,7 @@
           <a:p>
             <a:r>
               <a:rPr lang="en-US" dirty="0"/>
-              <a:t/>
+              <a:t>Key message: The workforce grew because the protocols held | Insight: Scope grows when coordination is structural, not heroic. | Talk track: Agent count over time, illustrative trajectory aligned with public milestones. | Transition: next up - "Agents own execution; the human owns judgment".</a:t>
             </a:r>
             <a:endParaRPr lang="en-US" dirty="0"/>
           </a:p>
@@ -1651,7 +1653,7 @@
           <a:p>
             <a:r>
               <a:rPr lang="en-US" dirty="0"/>
-              <a:t/>
+              <a:t>Key message: Agents own execution; the human owns judgment | Insight: The founder stopped being the bottleneck for execution and became the bottleneck for judgment. | Talk track: Ownership share per task type, illustrative. | Transition: next up - "When things break - and they will".</a:t>
             </a:r>
             <a:endParaRPr lang="en-US" dirty="0"/>
           </a:p>
@@ -1739,7 +1741,7 @@
           <a:p>
             <a:r>
               <a:rPr lang="en-US" dirty="0"/>
-              <a:t/>
+              <a:t>Key message: When things break - and they will | Talk track: Incidents end as written lessons, not war stories. | Transition: next up - "This is not a founder toy - it is an operating discipline".</a:t>
             </a:r>
             <a:endParaRPr lang="en-US" dirty="0"/>
           </a:p>
@@ -1827,7 +1829,7 @@
           <a:p>
             <a:r>
               <a:rPr lang="en-US" dirty="0"/>
-              <a:t/>
+              <a:t>Key message: This is not a founder toy - it is an operating discipline | Talk track: Disciplined orchestration beats a smarter chatbot in production. | Transition: next up - "Want an AI workforce that behaves like staff?".</a:t>
             </a:r>
             <a:endParaRPr lang="en-US" dirty="0"/>
           </a:p>
@@ -1915,7 +1917,7 @@
           <a:p>
             <a:r>
               <a:rPr lang="en-US" dirty="0"/>
-              <a:t/>
+              <a:t>Key message: Want an AI workforce that behaves like staff? | Transition: close with the call to action on the contact slide, invite questions.</a:t>
             </a:r>
             <a:endParaRPr lang="en-US" dirty="0"/>
           </a:p>
@@ -2003,7 +2005,7 @@
           <a:p>
             <a:r>
               <a:rPr lang="en-US" dirty="0"/>
-              <a:t/>
+              <a:t>Key message: What this deck covers | Agenda: Nine agents, nine mandates: the role map; The protocols: memory, evidence, rooms, queues; The request lifecycle, from brief to approval; The numbers: routing accuracy, checks, zero self-approvals; Division of labor: what agents own vs what the human owns; Failure handling: watchdog, honest red status, written lessons | Transition: next up - "Nine agents, nine mandates - no vibes".</a:t>
             </a:r>
             <a:endParaRPr lang="en-US" dirty="0"/>
           </a:p>
@@ -2091,7 +2093,7 @@
           <a:p>
             <a:r>
               <a:rPr lang="en-US" dirty="0"/>
-              <a:t/>
+              <a:t>Key message: Nine agents, nine mandates - no vibes | Talk track: Every mandate is scoped; a generalist that attempts everything owns nothing. | Transition: next up - "Each agent has a mandate and a guardrail".</a:t>
             </a:r>
             <a:endParaRPr lang="en-US" dirty="0"/>
           </a:p>
@@ -2179,7 +2181,7 @@
           <a:p>
             <a:r>
               <a:rPr lang="en-US" dirty="0"/>
-              <a:t/>
+              <a:t>Key message: Each agent has a mandate and a guardrail | Talk track: Six rows, nine agents - the specialists share one row and the same discipline. | Transition: next up - "How a piece of work moves through the workforce".</a:t>
             </a:r>
             <a:endParaRPr lang="en-US" dirty="0"/>
           </a:p>
@@ -2267,7 +2269,7 @@
           <a:p>
             <a:r>
               <a:rPr lang="en-US" dirty="0"/>
-              <a:t/>
+              <a:t>Key message: How a piece of work moves through the workforce | Talk track: Every arrow is a protocol, not a habit. | Transition: next up - "Shared memory beats private memory - and evidence is mandatory".</a:t>
             </a:r>
             <a:endParaRPr lang="en-US" dirty="0"/>
           </a:p>
@@ -2355,7 +2357,7 @@
           <a:p>
             <a:r>
               <a:rPr lang="en-US" dirty="0"/>
-              <a:t/>
+              <a:t>Key message: Shared memory beats private memory - and evidence is mandatory | Talk track: If the memory is muddy, every agent is confidently wrong in its own unique direction. | Transition: next up - "What lives in the memory of the company".</a:t>
             </a:r>
             <a:endParaRPr lang="en-US" dirty="0"/>
           </a:p>
@@ -2443,7 +2445,7 @@
           <a:p>
             <a:r>
               <a:rPr lang="en-US" dirty="0"/>
-              <a:t/>
+              <a:t>Key message: What lives in the memory of the company | Insight: Memory design is governance design: deciding what is a rule versus a status forces clarity. | Talk track: Illustrative composition; status is overwritten constantly while rules stay append-only. | Transition: next up - "A prompt is a wish; a protocol is law".</a:t>
             </a:r>
             <a:endParaRPr lang="en-US" dirty="0"/>
           </a:p>
@@ -2531,7 +2533,7 @@
           <a:p>
             <a:r>
               <a:rPr lang="en-US" dirty="0"/>
-              <a:t/>
+              <a:t>Key message: A prompt is a wish; a protocol is law | Talk track: Demote prompts to suggestions and write the rules down - the workforce gets smarter. | Transition: next up - "Reliability you can read from artifacts".</a:t>
             </a:r>
             <a:endParaRPr lang="en-US" dirty="0"/>
           </a:p>
@@ -2619,7 +2621,7 @@
           <a:p>
             <a:r>
               <a:rPr lang="en-US" dirty="0"/>
-              <a:t/>
+              <a:t>Key message: Reliability you can read from artifacts | Talk track: Honest evidence is the whole system: nothing here is claimed, everything is recorded. | Transition: next up - "The workforce grew because the protocols held".</a:t>
             </a:r>
             <a:endParaRPr lang="en-US" dirty="0"/>
           </a:p>
@@ -3040,7 +3042,7 @@
         </p:nvSpPr>
         <p:spPr>
           <a:xfrm>
-            <a:off x="822960" y="1783080"/>
+            <a:off x="822960" y="1737360"/>
             <a:ext cx="10515600" cy="457200"/>
           </a:xfrm>
           <a:prstGeom prst="rect">
@@ -3057,7 +3059,7 @@
               <a:buNone/>
             </a:pPr>
             <a:r>
-              <a:rPr lang="en-US" sz="1400" spc="400" kern="0" dirty="0">
+              <a:rPr lang="en-US" sz="1800" spc="400" kern="0" dirty="0">
                 <a:solidFill>
                   <a:srgbClr val="06B6D4"/>
                 </a:solidFill>
@@ -3067,7 +3069,7 @@
               </a:rPr>
               <a:t>ZALIN LABS · AI OPS</a:t>
             </a:r>
-            <a:endParaRPr lang="en-US" sz="1400" dirty="0"/>
+            <a:endParaRPr lang="en-US" sz="1800" dirty="0"/>
           </a:p>
         </p:txBody>
       </p:sp>
@@ -3079,7 +3081,7 @@
         </p:nvSpPr>
         <p:spPr>
           <a:xfrm>
-            <a:off x="822960" y="2286000"/>
+            <a:off x="822960" y="2240280"/>
             <a:ext cx="10607040" cy="1691640"/>
           </a:xfrm>
           <a:prstGeom prst="rect">
@@ -3118,8 +3120,8 @@
         </p:nvSpPr>
         <p:spPr>
           <a:xfrm>
-            <a:off x="822960" y="4023360"/>
-            <a:ext cx="10058400" cy="777240"/>
+            <a:off x="822960" y="3977640"/>
+            <a:ext cx="10058400" cy="822960"/>
           </a:xfrm>
           <a:prstGeom prst="rect">
             <a:avLst/>
@@ -3135,7 +3137,7 @@
               <a:buNone/>
             </a:pPr>
             <a:r>
-              <a:rPr lang="en-US" sz="1700" dirty="0">
+              <a:rPr lang="en-US" sz="2000" dirty="0">
                 <a:solidFill>
                   <a:srgbClr val="94A3B8"/>
                 </a:solidFill>
@@ -3145,7 +3147,7 @@
               </a:rPr>
               <a:t>How nine AI agents run a real company without colliding, lying, or forgetting</a:t>
             </a:r>
-            <a:endParaRPr lang="en-US" sz="1700" dirty="0"/>
+            <a:endParaRPr lang="en-US" sz="2000" dirty="0"/>
           </a:p>
         </p:txBody>
       </p:sp>
@@ -3157,7 +3159,7 @@
         </p:nvSpPr>
         <p:spPr>
           <a:xfrm>
-            <a:off x="822960" y="5440680"/>
+            <a:off x="822960" y="5349240"/>
             <a:ext cx="4114800" cy="0"/>
           </a:xfrm>
           <a:prstGeom prst="line">
@@ -3180,8 +3182,8 @@
         </p:nvSpPr>
         <p:spPr>
           <a:xfrm>
-            <a:off x="822960" y="5596128"/>
-            <a:ext cx="10058400" cy="457200"/>
+            <a:off x="822960" y="5532120"/>
+            <a:ext cx="10058400" cy="502920"/>
           </a:xfrm>
           <a:prstGeom prst="rect">
             <a:avLst/>
@@ -3197,9 +3199,9 @@
               <a:buNone/>
             </a:pPr>
             <a:r>
-              <a:rPr lang="en-US" sz="1250" dirty="0">
-                <a:solidFill>
-                  <a:srgbClr val="64748B"/>
+              <a:rPr lang="en-US" sz="1800" dirty="0">
+                <a:solidFill>
+                  <a:srgbClr val="8FA3BF"/>
                 </a:solidFill>
                 <a:latin typeface="Segoe UI" pitchFamily="34" charset="0"/>
                 <a:ea typeface="Segoe UI" pitchFamily="34" charset="-122"/>
@@ -3207,7 +3209,7 @@
               </a:rPr>
               <a:t>Rezalian Vatiady · Zalin Labs · 2026</a:t>
             </a:r>
-            <a:endParaRPr lang="en-US" sz="1250" dirty="0"/>
+            <a:endParaRPr lang="en-US" sz="1800" dirty="0"/>
           </a:p>
         </p:txBody>
       </p:sp>
@@ -3219,8 +3221,8 @@
         </p:nvSpPr>
         <p:spPr>
           <a:xfrm>
-            <a:off x="10698480" y="6382512"/>
-            <a:ext cx="1188720" cy="365760"/>
+            <a:off x="10698480" y="6309360"/>
+            <a:ext cx="1188720" cy="411480"/>
           </a:xfrm>
           <a:prstGeom prst="rect">
             <a:avLst/>
@@ -3236,9 +3238,9 @@
               <a:buNone/>
             </a:pPr>
             <a:r>
-              <a:rPr lang="en-US" sz="1000" dirty="0">
-                <a:solidFill>
-                  <a:srgbClr val="64748B"/>
+              <a:rPr lang="en-US" sz="1800" dirty="0">
+                <a:solidFill>
+                  <a:srgbClr val="8FA3BF"/>
                 </a:solidFill>
                 <a:latin typeface="Consolas" pitchFamily="34" charset="0"/>
                 <a:ea typeface="Consolas" pitchFamily="34" charset="-122"/>
@@ -3246,7 +3248,7 @@
               </a:rPr>
               <a:t>1 / 14</a:t>
             </a:r>
-            <a:endParaRPr lang="en-US" sz="1000" dirty="0"/>
+            <a:endParaRPr lang="en-US" sz="1800" dirty="0"/>
           </a:p>
         </p:txBody>
       </p:sp>
@@ -3330,8 +3332,8 @@
         </p:nvSpPr>
         <p:spPr>
           <a:xfrm>
-            <a:off x="822960" y="502920"/>
-            <a:ext cx="10515600" cy="365760"/>
+            <a:off x="822960" y="457200"/>
+            <a:ext cx="10515600" cy="411480"/>
           </a:xfrm>
           <a:prstGeom prst="rect">
             <a:avLst/>
@@ -3347,7 +3349,7 @@
               <a:buNone/>
             </a:pPr>
             <a:r>
-              <a:rPr lang="en-US" sz="1200" spc="300" kern="0" dirty="0">
+              <a:rPr lang="en-US" sz="1800" spc="300" kern="0" dirty="0">
                 <a:solidFill>
                   <a:srgbClr val="06B6D4"/>
                 </a:solidFill>
@@ -3357,7 +3359,7 @@
               </a:rPr>
               <a:t>GROWTH</a:t>
             </a:r>
-            <a:endParaRPr lang="en-US" sz="1200" dirty="0"/>
+            <a:endParaRPr lang="en-US" sz="1800" dirty="0"/>
           </a:p>
         </p:txBody>
       </p:sp>
@@ -3408,7 +3410,7 @@
         </p:nvGraphicFramePr>
         <p:xfrm>
           <a:off x="822960" y="1874520"/>
-          <a:ext cx="10515600" cy="3337560"/>
+          <a:ext cx="10515600" cy="3246120"/>
         </p:xfrm>
         <a:graphic xmlns:a="http://schemas.openxmlformats.org/drawingml/2006/main">
           <a:graphicData uri="http://schemas.openxmlformats.org/drawingml/2006/chart">
@@ -3424,7 +3426,7 @@
         </p:nvSpPr>
         <p:spPr>
           <a:xfrm>
-            <a:off x="822960" y="5413248"/>
+            <a:off x="822960" y="5321808"/>
             <a:ext cx="10515600" cy="0"/>
           </a:xfrm>
           <a:prstGeom prst="line">
@@ -3447,8 +3449,8 @@
         </p:nvSpPr>
         <p:spPr>
           <a:xfrm>
-            <a:off x="822960" y="5504688"/>
-            <a:ext cx="10424160" cy="411480"/>
+            <a:off x="822960" y="5394960"/>
+            <a:ext cx="10424160" cy="502920"/>
           </a:xfrm>
           <a:prstGeom prst="rect">
             <a:avLst/>
@@ -3464,7 +3466,7 @@
               <a:buNone/>
             </a:pPr>
             <a:r>
-              <a:rPr lang="en-US" sz="1300" i="1" dirty="0">
+              <a:rPr lang="en-US" sz="1800" i="1" dirty="0">
                 <a:solidFill>
                   <a:srgbClr val="06B6D4"/>
                 </a:solidFill>
@@ -3474,7 +3476,7 @@
               </a:rPr>
               <a:t>→  Scope grows when coordination is structural, not heroic.</a:t>
             </a:r>
-            <a:endParaRPr lang="en-US" sz="1300" dirty="0"/>
+            <a:endParaRPr lang="en-US" sz="1800" dirty="0"/>
           </a:p>
         </p:txBody>
       </p:sp>
@@ -3509,8 +3511,8 @@
         </p:nvSpPr>
         <p:spPr>
           <a:xfrm>
-            <a:off x="822960" y="6053328"/>
-            <a:ext cx="9692640" cy="457200"/>
+            <a:off x="822960" y="6035040"/>
+            <a:ext cx="10424160" cy="566928"/>
           </a:xfrm>
           <a:prstGeom prst="rect">
             <a:avLst/>
@@ -3526,9 +3528,9 @@
               <a:buNone/>
             </a:pPr>
             <a:r>
-              <a:rPr lang="en-US" sz="1150" dirty="0">
-                <a:solidFill>
-                  <a:srgbClr val="64748B"/>
+              <a:rPr lang="en-US" sz="1800" dirty="0">
+                <a:solidFill>
+                  <a:srgbClr val="8FA3BF"/>
                 </a:solidFill>
                 <a:latin typeface="Segoe UI" pitchFamily="34" charset="0"/>
                 <a:ea typeface="Segoe UI" pitchFamily="34" charset="-122"/>
@@ -3536,7 +3538,7 @@
               </a:rPr>
               <a:t>Agent count over time, illustrative trajectory aligned with public milestones.</a:t>
             </a:r>
-            <a:endParaRPr lang="en-US" sz="1150" dirty="0"/>
+            <a:endParaRPr lang="en-US" sz="1800" dirty="0"/>
           </a:p>
         </p:txBody>
       </p:sp>
@@ -3548,8 +3550,8 @@
         </p:nvSpPr>
         <p:spPr>
           <a:xfrm>
-            <a:off x="10698480" y="6382512"/>
-            <a:ext cx="1188720" cy="365760"/>
+            <a:off x="10698480" y="6309360"/>
+            <a:ext cx="1188720" cy="411480"/>
           </a:xfrm>
           <a:prstGeom prst="rect">
             <a:avLst/>
@@ -3565,9 +3567,9 @@
               <a:buNone/>
             </a:pPr>
             <a:r>
-              <a:rPr lang="en-US" sz="1000" dirty="0">
-                <a:solidFill>
-                  <a:srgbClr val="64748B"/>
+              <a:rPr lang="en-US" sz="1800" dirty="0">
+                <a:solidFill>
+                  <a:srgbClr val="8FA3BF"/>
                 </a:solidFill>
                 <a:latin typeface="Consolas" pitchFamily="34" charset="0"/>
                 <a:ea typeface="Consolas" pitchFamily="34" charset="-122"/>
@@ -3575,7 +3577,7 @@
               </a:rPr>
               <a:t>10 / 14</a:t>
             </a:r>
-            <a:endParaRPr lang="en-US" sz="1000" dirty="0"/>
+            <a:endParaRPr lang="en-US" sz="1800" dirty="0"/>
           </a:p>
         </p:txBody>
       </p:sp>
@@ -3659,8 +3661,8 @@
         </p:nvSpPr>
         <p:spPr>
           <a:xfrm>
-            <a:off x="822960" y="502920"/>
-            <a:ext cx="10515600" cy="365760"/>
+            <a:off x="822960" y="457200"/>
+            <a:ext cx="10515600" cy="411480"/>
           </a:xfrm>
           <a:prstGeom prst="rect">
             <a:avLst/>
@@ -3676,7 +3678,7 @@
               <a:buNone/>
             </a:pPr>
             <a:r>
-              <a:rPr lang="en-US" sz="1200" spc="300" kern="0" dirty="0">
+              <a:rPr lang="en-US" sz="1800" spc="300" kern="0" dirty="0">
                 <a:solidFill>
                   <a:srgbClr val="06B6D4"/>
                 </a:solidFill>
@@ -3686,7 +3688,7 @@
               </a:rPr>
               <a:t>DIVISION OF LABOR</a:t>
             </a:r>
-            <a:endParaRPr lang="en-US" sz="1200" dirty="0"/>
+            <a:endParaRPr lang="en-US" sz="1800" dirty="0"/>
           </a:p>
         </p:txBody>
       </p:sp>
@@ -3737,7 +3739,7 @@
         </p:nvGraphicFramePr>
         <p:xfrm>
           <a:off x="822960" y="1874520"/>
-          <a:ext cx="10515600" cy="3337560"/>
+          <a:ext cx="10515600" cy="3246120"/>
         </p:xfrm>
         <a:graphic xmlns:a="http://schemas.openxmlformats.org/drawingml/2006/main">
           <a:graphicData uri="http://schemas.openxmlformats.org/drawingml/2006/chart">
@@ -3753,7 +3755,7 @@
         </p:nvSpPr>
         <p:spPr>
           <a:xfrm>
-            <a:off x="822960" y="5413248"/>
+            <a:off x="822960" y="5321808"/>
             <a:ext cx="10515600" cy="0"/>
           </a:xfrm>
           <a:prstGeom prst="line">
@@ -3776,8 +3778,8 @@
         </p:nvSpPr>
         <p:spPr>
           <a:xfrm>
-            <a:off x="822960" y="5504688"/>
-            <a:ext cx="10424160" cy="411480"/>
+            <a:off x="822960" y="5394960"/>
+            <a:ext cx="10424160" cy="502920"/>
           </a:xfrm>
           <a:prstGeom prst="rect">
             <a:avLst/>
@@ -3793,7 +3795,7 @@
               <a:buNone/>
             </a:pPr>
             <a:r>
-              <a:rPr lang="en-US" sz="1300" i="1" dirty="0">
+              <a:rPr lang="en-US" sz="1800" i="1" dirty="0">
                 <a:solidFill>
                   <a:srgbClr val="06B6D4"/>
                 </a:solidFill>
@@ -3803,7 +3805,7 @@
               </a:rPr>
               <a:t>→  The founder stopped being the bottleneck for execution and became the bottleneck for judgment.</a:t>
             </a:r>
-            <a:endParaRPr lang="en-US" sz="1300" dirty="0"/>
+            <a:endParaRPr lang="en-US" sz="1800" dirty="0"/>
           </a:p>
         </p:txBody>
       </p:sp>
@@ -3838,8 +3840,8 @@
         </p:nvSpPr>
         <p:spPr>
           <a:xfrm>
-            <a:off x="822960" y="6053328"/>
-            <a:ext cx="9692640" cy="457200"/>
+            <a:off x="822960" y="6035040"/>
+            <a:ext cx="10424160" cy="566928"/>
           </a:xfrm>
           <a:prstGeom prst="rect">
             <a:avLst/>
@@ -3855,9 +3857,9 @@
               <a:buNone/>
             </a:pPr>
             <a:r>
-              <a:rPr lang="en-US" sz="1150" dirty="0">
-                <a:solidFill>
-                  <a:srgbClr val="64748B"/>
+              <a:rPr lang="en-US" sz="1800" dirty="0">
+                <a:solidFill>
+                  <a:srgbClr val="8FA3BF"/>
                 </a:solidFill>
                 <a:latin typeface="Segoe UI" pitchFamily="34" charset="0"/>
                 <a:ea typeface="Segoe UI" pitchFamily="34" charset="-122"/>
@@ -3865,7 +3867,7 @@
               </a:rPr>
               <a:t>Ownership share per task type, illustrative.</a:t>
             </a:r>
-            <a:endParaRPr lang="en-US" sz="1150" dirty="0"/>
+            <a:endParaRPr lang="en-US" sz="1800" dirty="0"/>
           </a:p>
         </p:txBody>
       </p:sp>
@@ -3877,8 +3879,8 @@
         </p:nvSpPr>
         <p:spPr>
           <a:xfrm>
-            <a:off x="10698480" y="6382512"/>
-            <a:ext cx="1188720" cy="365760"/>
+            <a:off x="10698480" y="6309360"/>
+            <a:ext cx="1188720" cy="411480"/>
           </a:xfrm>
           <a:prstGeom prst="rect">
             <a:avLst/>
@@ -3894,9 +3896,9 @@
               <a:buNone/>
             </a:pPr>
             <a:r>
-              <a:rPr lang="en-US" sz="1000" dirty="0">
-                <a:solidFill>
-                  <a:srgbClr val="64748B"/>
+              <a:rPr lang="en-US" sz="1800" dirty="0">
+                <a:solidFill>
+                  <a:srgbClr val="8FA3BF"/>
                 </a:solidFill>
                 <a:latin typeface="Consolas" pitchFamily="34" charset="0"/>
                 <a:ea typeface="Consolas" pitchFamily="34" charset="-122"/>
@@ -3904,7 +3906,7 @@
               </a:rPr>
               <a:t>11 / 14</a:t>
             </a:r>
-            <a:endParaRPr lang="en-US" sz="1000" dirty="0"/>
+            <a:endParaRPr lang="en-US" sz="1800" dirty="0"/>
           </a:p>
         </p:txBody>
       </p:sp>
@@ -3988,8 +3990,8 @@
         </p:nvSpPr>
         <p:spPr>
           <a:xfrm>
-            <a:off x="822960" y="502920"/>
-            <a:ext cx="10515600" cy="365760"/>
+            <a:off x="822960" y="457200"/>
+            <a:ext cx="10515600" cy="411480"/>
           </a:xfrm>
           <a:prstGeom prst="rect">
             <a:avLst/>
@@ -4005,7 +4007,7 @@
               <a:buNone/>
             </a:pPr>
             <a:r>
-              <a:rPr lang="en-US" sz="1200" spc="300" kern="0" dirty="0">
+              <a:rPr lang="en-US" sz="1800" spc="300" kern="0" dirty="0">
                 <a:solidFill>
                   <a:srgbClr val="06B6D4"/>
                 </a:solidFill>
@@ -4015,7 +4017,7 @@
               </a:rPr>
               <a:t>FAILURE HANDLING</a:t>
             </a:r>
-            <a:endParaRPr lang="en-US" sz="1200" dirty="0"/>
+            <a:endParaRPr lang="en-US" sz="1800" dirty="0"/>
           </a:p>
         </p:txBody>
       </p:sp>
@@ -4066,7 +4068,7 @@
         </p:nvSpPr>
         <p:spPr>
           <a:xfrm>
-            <a:off x="1371600" y="3035808"/>
+            <a:off x="1371600" y="2907792"/>
             <a:ext cx="9464040" cy="0"/>
           </a:xfrm>
           <a:prstGeom prst="line">
@@ -4089,7 +4091,7 @@
         </p:nvSpPr>
         <p:spPr>
           <a:xfrm>
-            <a:off x="1289304" y="2953512"/>
+            <a:off x="1289304" y="2825496"/>
             <a:ext cx="164592" cy="164592"/>
           </a:xfrm>
           <a:prstGeom prst="ellipse">
@@ -4114,8 +4116,8 @@
         </p:nvSpPr>
         <p:spPr>
           <a:xfrm>
-            <a:off x="342900" y="2395728"/>
-            <a:ext cx="2057400" cy="365760"/>
+            <a:off x="297180" y="2212848"/>
+            <a:ext cx="2148840" cy="384048"/>
           </a:xfrm>
           <a:prstGeom prst="rect">
             <a:avLst/>
@@ -4131,7 +4133,7 @@
               <a:buNone/>
             </a:pPr>
             <a:r>
-              <a:rPr lang="en-US" sz="1100" b="1" dirty="0">
+              <a:rPr lang="en-US" sz="1800" b="1" dirty="0">
                 <a:solidFill>
                   <a:srgbClr val="3B82F6"/>
                 </a:solidFill>
@@ -4141,7 +4143,7 @@
               </a:rPr>
               <a:t>Detect</a:t>
             </a:r>
-            <a:endParaRPr lang="en-US" sz="1100" dirty="0"/>
+            <a:endParaRPr lang="en-US" sz="1800" dirty="0"/>
           </a:p>
         </p:txBody>
       </p:sp>
@@ -4153,8 +4155,8 @@
         </p:nvSpPr>
         <p:spPr>
           <a:xfrm>
-            <a:off x="342900" y="3310128"/>
-            <a:ext cx="2057400" cy="566928"/>
+            <a:off x="297180" y="3200400"/>
+            <a:ext cx="2148840" cy="713232"/>
           </a:xfrm>
           <a:prstGeom prst="rect">
             <a:avLst/>
@@ -4170,7 +4172,7 @@
               <a:buNone/>
             </a:pPr>
             <a:r>
-              <a:rPr lang="en-US" sz="1250" b="1" dirty="0">
+              <a:rPr lang="en-US" sz="1800" b="1" dirty="0">
                 <a:solidFill>
                   <a:srgbClr val="FFFFFF"/>
                 </a:solidFill>
@@ -4180,7 +4182,7 @@
               </a:rPr>
               <a:t>The watchdog notices first</a:t>
             </a:r>
-            <a:endParaRPr lang="en-US" sz="1250" dirty="0"/>
+            <a:endParaRPr lang="en-US" sz="1800" dirty="0"/>
           </a:p>
         </p:txBody>
       </p:sp>
@@ -4192,8 +4194,8 @@
         </p:nvSpPr>
         <p:spPr>
           <a:xfrm>
-            <a:off x="342900" y="3895344"/>
-            <a:ext cx="2057400" cy="1234440"/>
+            <a:off x="297180" y="3931920"/>
+            <a:ext cx="2148840" cy="1417320"/>
           </a:xfrm>
           <a:prstGeom prst="rect">
             <a:avLst/>
@@ -4209,7 +4211,7 @@
               <a:buNone/>
             </a:pPr>
             <a:r>
-              <a:rPr lang="en-US" sz="1000" dirty="0">
+              <a:rPr lang="en-US" sz="1800" dirty="0">
                 <a:solidFill>
                   <a:srgbClr val="CBD5E1"/>
                 </a:solidFill>
@@ -4219,7 +4221,7 @@
               </a:rPr>
               <a:t>Dead agents and misbehaving machines are detected and recovered automatically.</a:t>
             </a:r>
-            <a:endParaRPr lang="en-US" sz="1000" dirty="0"/>
+            <a:endParaRPr lang="en-US" sz="1800" dirty="0"/>
           </a:p>
         </p:txBody>
       </p:sp>
@@ -4231,7 +4233,7 @@
         </p:nvSpPr>
         <p:spPr>
           <a:xfrm>
-            <a:off x="3655314" y="2953512"/>
+            <a:off x="3655314" y="2825496"/>
             <a:ext cx="164592" cy="164592"/>
           </a:xfrm>
           <a:prstGeom prst="ellipse">
@@ -4256,8 +4258,8 @@
         </p:nvSpPr>
         <p:spPr>
           <a:xfrm>
-            <a:off x="2708910" y="2395728"/>
-            <a:ext cx="2057400" cy="365760"/>
+            <a:off x="2663190" y="2212848"/>
+            <a:ext cx="2148840" cy="384048"/>
           </a:xfrm>
           <a:prstGeom prst="rect">
             <a:avLst/>
@@ -4273,7 +4275,7 @@
               <a:buNone/>
             </a:pPr>
             <a:r>
-              <a:rPr lang="en-US" sz="1100" b="1" dirty="0">
+              <a:rPr lang="en-US" sz="1800" b="1" dirty="0">
                 <a:solidFill>
                   <a:srgbClr val="06B6D4"/>
                 </a:solidFill>
@@ -4283,7 +4285,7 @@
               </a:rPr>
               <a:t>Report</a:t>
             </a:r>
-            <a:endParaRPr lang="en-US" sz="1100" dirty="0"/>
+            <a:endParaRPr lang="en-US" sz="1800" dirty="0"/>
           </a:p>
         </p:txBody>
       </p:sp>
@@ -4295,8 +4297,8 @@
         </p:nvSpPr>
         <p:spPr>
           <a:xfrm>
-            <a:off x="2708910" y="3310128"/>
-            <a:ext cx="2057400" cy="566928"/>
+            <a:off x="2663190" y="3200400"/>
+            <a:ext cx="2148840" cy="713232"/>
           </a:xfrm>
           <a:prstGeom prst="rect">
             <a:avLst/>
@@ -4312,7 +4314,7 @@
               <a:buNone/>
             </a:pPr>
             <a:r>
-              <a:rPr lang="en-US" sz="1250" b="1" dirty="0">
+              <a:rPr lang="en-US" sz="1800" b="1" dirty="0">
                 <a:solidFill>
                   <a:srgbClr val="FFFFFF"/>
                 </a:solidFill>
@@ -4322,7 +4324,7 @@
               </a:rPr>
               <a:t>Honest red status</a:t>
             </a:r>
-            <a:endParaRPr lang="en-US" sz="1250" dirty="0"/>
+            <a:endParaRPr lang="en-US" sz="1800" dirty="0"/>
           </a:p>
         </p:txBody>
       </p:sp>
@@ -4334,8 +4336,8 @@
         </p:nvSpPr>
         <p:spPr>
           <a:xfrm>
-            <a:off x="2708910" y="3895344"/>
-            <a:ext cx="2057400" cy="1234440"/>
+            <a:off x="2663190" y="3931920"/>
+            <a:ext cx="2148840" cy="1417320"/>
           </a:xfrm>
           <a:prstGeom prst="rect">
             <a:avLst/>
@@ -4351,7 +4353,7 @@
               <a:buNone/>
             </a:pPr>
             <a:r>
-              <a:rPr lang="en-US" sz="1000" dirty="0">
+              <a:rPr lang="en-US" sz="1800" dirty="0">
                 <a:solidFill>
                   <a:srgbClr val="CBD5E1"/>
                 </a:solidFill>
@@ -4361,7 +4363,7 @@
               </a:rPr>
               <a:t>A red status reported honestly beats a fake green status, every time.</a:t>
             </a:r>
-            <a:endParaRPr lang="en-US" sz="1000" dirty="0"/>
+            <a:endParaRPr lang="en-US" sz="1800" dirty="0"/>
           </a:p>
         </p:txBody>
       </p:sp>
@@ -4373,7 +4375,7 @@
         </p:nvSpPr>
         <p:spPr>
           <a:xfrm>
-            <a:off x="6021324" y="2953512"/>
+            <a:off x="6021324" y="2825496"/>
             <a:ext cx="164592" cy="164592"/>
           </a:xfrm>
           <a:prstGeom prst="ellipse">
@@ -4398,8 +4400,8 @@
         </p:nvSpPr>
         <p:spPr>
           <a:xfrm>
-            <a:off x="5074920" y="2395728"/>
-            <a:ext cx="2057400" cy="365760"/>
+            <a:off x="5029200" y="2212848"/>
+            <a:ext cx="2148840" cy="384048"/>
           </a:xfrm>
           <a:prstGeom prst="rect">
             <a:avLst/>
@@ -4415,7 +4417,7 @@
               <a:buNone/>
             </a:pPr>
             <a:r>
-              <a:rPr lang="en-US" sz="1100" b="1" dirty="0">
+              <a:rPr lang="en-US" sz="1800" b="1" dirty="0">
                 <a:solidFill>
                   <a:srgbClr val="3B82F6"/>
                 </a:solidFill>
@@ -4425,7 +4427,7 @@
               </a:rPr>
               <a:t>Contain</a:t>
             </a:r>
-            <a:endParaRPr lang="en-US" sz="1100" dirty="0"/>
+            <a:endParaRPr lang="en-US" sz="1800" dirty="0"/>
           </a:p>
         </p:txBody>
       </p:sp>
@@ -4437,8 +4439,8 @@
         </p:nvSpPr>
         <p:spPr>
           <a:xfrm>
-            <a:off x="5074920" y="3310128"/>
-            <a:ext cx="2057400" cy="566928"/>
+            <a:off x="5029200" y="3200400"/>
+            <a:ext cx="2148840" cy="713232"/>
           </a:xfrm>
           <a:prstGeom prst="rect">
             <a:avLst/>
@@ -4454,7 +4456,7 @@
               <a:buNone/>
             </a:pPr>
             <a:r>
-              <a:rPr lang="en-US" sz="1250" b="1" dirty="0">
+              <a:rPr lang="en-US" sz="1800" b="1" dirty="0">
                 <a:solidFill>
                   <a:srgbClr val="FFFFFF"/>
                 </a:solidFill>
@@ -4464,7 +4466,7 @@
               </a:rPr>
               <a:t>Queues hold the line</a:t>
             </a:r>
-            <a:endParaRPr lang="en-US" sz="1250" dirty="0"/>
+            <a:endParaRPr lang="en-US" sz="1800" dirty="0"/>
           </a:p>
         </p:txBody>
       </p:sp>
@@ -4476,8 +4478,8 @@
         </p:nvSpPr>
         <p:spPr>
           <a:xfrm>
-            <a:off x="5074920" y="3895344"/>
-            <a:ext cx="2057400" cy="1234440"/>
+            <a:off x="5029200" y="3931920"/>
+            <a:ext cx="2148840" cy="1417320"/>
           </a:xfrm>
           <a:prstGeom prst="rect">
             <a:avLst/>
@@ -4493,7 +4495,7 @@
               <a:buNone/>
             </a:pPr>
             <a:r>
-              <a:rPr lang="en-US" sz="1000" dirty="0">
+              <a:rPr lang="en-US" sz="1800" dirty="0">
                 <a:solidFill>
                   <a:srgbClr val="CBD5E1"/>
                 </a:solidFill>
@@ -4503,7 +4505,7 @@
               </a:rPr>
               <a:t>Per-agent queues isolate the blast radius so parallel work keeps moving.</a:t>
             </a:r>
-            <a:endParaRPr lang="en-US" sz="1000" dirty="0"/>
+            <a:endParaRPr lang="en-US" sz="1800" dirty="0"/>
           </a:p>
         </p:txBody>
       </p:sp>
@@ -4515,7 +4517,7 @@
         </p:nvSpPr>
         <p:spPr>
           <a:xfrm>
-            <a:off x="8387334" y="2953512"/>
+            <a:off x="8387334" y="2825496"/>
             <a:ext cx="164592" cy="164592"/>
           </a:xfrm>
           <a:prstGeom prst="ellipse">
@@ -4540,8 +4542,8 @@
         </p:nvSpPr>
         <p:spPr>
           <a:xfrm>
-            <a:off x="7440930" y="2395728"/>
-            <a:ext cx="2057400" cy="365760"/>
+            <a:off x="7395210" y="2212848"/>
+            <a:ext cx="2148840" cy="384048"/>
           </a:xfrm>
           <a:prstGeom prst="rect">
             <a:avLst/>
@@ -4557,7 +4559,7 @@
               <a:buNone/>
             </a:pPr>
             <a:r>
-              <a:rPr lang="en-US" sz="1100" b="1" dirty="0">
+              <a:rPr lang="en-US" sz="1800" b="1" dirty="0">
                 <a:solidFill>
                   <a:srgbClr val="06B6D4"/>
                 </a:solidFill>
@@ -4567,7 +4569,7 @@
               </a:rPr>
               <a:t>Learn</a:t>
             </a:r>
-            <a:endParaRPr lang="en-US" sz="1100" dirty="0"/>
+            <a:endParaRPr lang="en-US" sz="1800" dirty="0"/>
           </a:p>
         </p:txBody>
       </p:sp>
@@ -4579,8 +4581,8 @@
         </p:nvSpPr>
         <p:spPr>
           <a:xfrm>
-            <a:off x="7440930" y="3310128"/>
-            <a:ext cx="2057400" cy="566928"/>
+            <a:off x="7395210" y="3200400"/>
+            <a:ext cx="2148840" cy="713232"/>
           </a:xfrm>
           <a:prstGeom prst="rect">
             <a:avLst/>
@@ -4596,7 +4598,7 @@
               <a:buNone/>
             </a:pPr>
             <a:r>
-              <a:rPr lang="en-US" sz="1250" b="1" dirty="0">
+              <a:rPr lang="en-US" sz="1800" b="1" dirty="0">
                 <a:solidFill>
                   <a:srgbClr val="FFFFFF"/>
                 </a:solidFill>
@@ -4606,7 +4608,7 @@
               </a:rPr>
               <a:t>The incident becomes a lesson</a:t>
             </a:r>
-            <a:endParaRPr lang="en-US" sz="1250" dirty="0"/>
+            <a:endParaRPr lang="en-US" sz="1800" dirty="0"/>
           </a:p>
         </p:txBody>
       </p:sp>
@@ -4618,8 +4620,8 @@
         </p:nvSpPr>
         <p:spPr>
           <a:xfrm>
-            <a:off x="7440930" y="3895344"/>
-            <a:ext cx="2057400" cy="1234440"/>
+            <a:off x="7395210" y="3931920"/>
+            <a:ext cx="2148840" cy="1417320"/>
           </a:xfrm>
           <a:prstGeom prst="rect">
             <a:avLst/>
@@ -4635,7 +4637,7 @@
               <a:buNone/>
             </a:pPr>
             <a:r>
-              <a:rPr lang="en-US" sz="1000" dirty="0">
+              <a:rPr lang="en-US" sz="1800" dirty="0">
                 <a:solidFill>
                   <a:srgbClr val="CBD5E1"/>
                 </a:solidFill>
@@ -4645,7 +4647,7 @@
               </a:rPr>
               <a:t>What broke, why, and the fix - attached to evidence and never deleted.</a:t>
             </a:r>
-            <a:endParaRPr lang="en-US" sz="1000" dirty="0"/>
+            <a:endParaRPr lang="en-US" sz="1800" dirty="0"/>
           </a:p>
         </p:txBody>
       </p:sp>
@@ -4657,7 +4659,7 @@
         </p:nvSpPr>
         <p:spPr>
           <a:xfrm>
-            <a:off x="10753344" y="2953512"/>
+            <a:off x="10753344" y="2825496"/>
             <a:ext cx="164592" cy="164592"/>
           </a:xfrm>
           <a:prstGeom prst="ellipse">
@@ -4682,8 +4684,8 @@
         </p:nvSpPr>
         <p:spPr>
           <a:xfrm>
-            <a:off x="9806940" y="2395728"/>
-            <a:ext cx="2057400" cy="365760"/>
+            <a:off x="9761220" y="2212848"/>
+            <a:ext cx="2148840" cy="384048"/>
           </a:xfrm>
           <a:prstGeom prst="rect">
             <a:avLst/>
@@ -4699,7 +4701,7 @@
               <a:buNone/>
             </a:pPr>
             <a:r>
-              <a:rPr lang="en-US" sz="1100" b="1" dirty="0">
+              <a:rPr lang="en-US" sz="1800" b="1" dirty="0">
                 <a:solidFill>
                   <a:srgbClr val="3B82F6"/>
                 </a:solidFill>
@@ -4709,7 +4711,7 @@
               </a:rPr>
               <a:t>Amend</a:t>
             </a:r>
-            <a:endParaRPr lang="en-US" sz="1100" dirty="0"/>
+            <a:endParaRPr lang="en-US" sz="1800" dirty="0"/>
           </a:p>
         </p:txBody>
       </p:sp>
@@ -4721,8 +4723,8 @@
         </p:nvSpPr>
         <p:spPr>
           <a:xfrm>
-            <a:off x="9806940" y="3310128"/>
-            <a:ext cx="2057400" cy="566928"/>
+            <a:off x="9761220" y="3200400"/>
+            <a:ext cx="2148840" cy="713232"/>
           </a:xfrm>
           <a:prstGeom prst="rect">
             <a:avLst/>
@@ -4738,7 +4740,7 @@
               <a:buNone/>
             </a:pPr>
             <a:r>
-              <a:rPr lang="en-US" sz="1250" b="1" dirty="0">
+              <a:rPr lang="en-US" sz="1800" b="1" dirty="0">
                 <a:solidFill>
                   <a:srgbClr val="FFFFFF"/>
                 </a:solidFill>
@@ -4748,7 +4750,7 @@
               </a:rPr>
               <a:t>The protocol gets smarter</a:t>
             </a:r>
-            <a:endParaRPr lang="en-US" sz="1250" dirty="0"/>
+            <a:endParaRPr lang="en-US" sz="1800" dirty="0"/>
           </a:p>
         </p:txBody>
       </p:sp>
@@ -4760,8 +4762,8 @@
         </p:nvSpPr>
         <p:spPr>
           <a:xfrm>
-            <a:off x="9806940" y="3895344"/>
-            <a:ext cx="2057400" cy="1234440"/>
+            <a:off x="9761220" y="3931920"/>
+            <a:ext cx="2148840" cy="1417320"/>
           </a:xfrm>
           <a:prstGeom prst="rect">
             <a:avLst/>
@@ -4777,7 +4779,7 @@
               <a:buNone/>
             </a:pPr>
             <a:r>
-              <a:rPr lang="en-US" sz="1000" dirty="0">
+              <a:rPr lang="en-US" sz="1800" dirty="0">
                 <a:solidFill>
                   <a:srgbClr val="CBD5E1"/>
                 </a:solidFill>
@@ -4787,7 +4789,7 @@
               </a:rPr>
               <a:t>The protocol is amended, and the whole workforce inherits the fix.</a:t>
             </a:r>
-            <a:endParaRPr lang="en-US" sz="1000" dirty="0"/>
+            <a:endParaRPr lang="en-US" sz="1800" dirty="0"/>
           </a:p>
         </p:txBody>
       </p:sp>
@@ -4822,8 +4824,8 @@
         </p:nvSpPr>
         <p:spPr>
           <a:xfrm>
-            <a:off x="822960" y="6053328"/>
-            <a:ext cx="9692640" cy="457200"/>
+            <a:off x="822960" y="6035040"/>
+            <a:ext cx="10424160" cy="566928"/>
           </a:xfrm>
           <a:prstGeom prst="rect">
             <a:avLst/>
@@ -4839,9 +4841,9 @@
               <a:buNone/>
             </a:pPr>
             <a:r>
-              <a:rPr lang="en-US" sz="1150" dirty="0">
-                <a:solidFill>
-                  <a:srgbClr val="64748B"/>
+              <a:rPr lang="en-US" sz="1800" dirty="0">
+                <a:solidFill>
+                  <a:srgbClr val="8FA3BF"/>
                 </a:solidFill>
                 <a:latin typeface="Segoe UI" pitchFamily="34" charset="0"/>
                 <a:ea typeface="Segoe UI" pitchFamily="34" charset="-122"/>
@@ -4849,7 +4851,7 @@
               </a:rPr>
               <a:t>Incidents end as written lessons, not war stories.</a:t>
             </a:r>
-            <a:endParaRPr lang="en-US" sz="1150" dirty="0"/>
+            <a:endParaRPr lang="en-US" sz="1800" dirty="0"/>
           </a:p>
         </p:txBody>
       </p:sp>
@@ -4861,8 +4863,8 @@
         </p:nvSpPr>
         <p:spPr>
           <a:xfrm>
-            <a:off x="10698480" y="6382512"/>
-            <a:ext cx="1188720" cy="365760"/>
+            <a:off x="10698480" y="6309360"/>
+            <a:ext cx="1188720" cy="411480"/>
           </a:xfrm>
           <a:prstGeom prst="rect">
             <a:avLst/>
@@ -4878,9 +4880,9 @@
               <a:buNone/>
             </a:pPr>
             <a:r>
-              <a:rPr lang="en-US" sz="1000" dirty="0">
-                <a:solidFill>
-                  <a:srgbClr val="64748B"/>
+              <a:rPr lang="en-US" sz="1800" dirty="0">
+                <a:solidFill>
+                  <a:srgbClr val="8FA3BF"/>
                 </a:solidFill>
                 <a:latin typeface="Consolas" pitchFamily="34" charset="0"/>
                 <a:ea typeface="Consolas" pitchFamily="34" charset="-122"/>
@@ -4888,7 +4890,7 @@
               </a:rPr>
               <a:t>12 / 14</a:t>
             </a:r>
-            <a:endParaRPr lang="en-US" sz="1000" dirty="0"/>
+            <a:endParaRPr lang="en-US" sz="1800" dirty="0"/>
           </a:p>
         </p:txBody>
       </p:sp>
@@ -4972,8 +4974,8 @@
         </p:nvSpPr>
         <p:spPr>
           <a:xfrm>
-            <a:off x="822960" y="502920"/>
-            <a:ext cx="10515600" cy="365760"/>
+            <a:off x="822960" y="457200"/>
+            <a:ext cx="10515600" cy="411480"/>
           </a:xfrm>
           <a:prstGeom prst="rect">
             <a:avLst/>
@@ -4989,7 +4991,7 @@
               <a:buNone/>
             </a:pPr>
             <a:r>
-              <a:rPr lang="en-US" sz="1200" spc="300" kern="0" dirty="0">
+              <a:rPr lang="en-US" sz="1800" spc="300" kern="0" dirty="0">
                 <a:solidFill>
                   <a:srgbClr val="06B6D4"/>
                 </a:solidFill>
@@ -4999,7 +5001,7 @@
               </a:rPr>
               <a:t>WHY IT MATTERS</a:t>
             </a:r>
-            <a:endParaRPr lang="en-US" sz="1200" dirty="0"/>
+            <a:endParaRPr lang="en-US" sz="1800" dirty="0"/>
           </a:p>
         </p:txBody>
       </p:sp>
@@ -5050,8 +5052,8 @@
         </p:nvSpPr>
         <p:spPr>
           <a:xfrm>
-            <a:off x="868680" y="2011680"/>
-            <a:ext cx="10424160" cy="3566160"/>
+            <a:off x="868680" y="1965960"/>
+            <a:ext cx="10424160" cy="3840480"/>
           </a:xfrm>
           <a:prstGeom prst="rect">
             <a:avLst/>
@@ -5074,7 +5076,7 @@
               <a:buChar char="▸"/>
             </a:pPr>
             <a:r>
-              <a:rPr lang="en-US" sz="1600" dirty="0">
+              <a:rPr lang="en-US" sz="2000" dirty="0">
                 <a:solidFill>
                   <a:srgbClr val="CBD5E1"/>
                 </a:solidFill>
@@ -5084,7 +5086,7 @@
               </a:rPr>
               <a:t>If you run a team or buy AI-built software, the same protocols make outputs auditable.</a:t>
             </a:r>
-            <a:endParaRPr lang="en-US" sz="1600" dirty="0"/>
+            <a:endParaRPr lang="en-US" sz="2000" dirty="0"/>
           </a:p>
           <a:p>
             <a:pPr marL="342900" indent="-342900">
@@ -5098,7 +5100,7 @@
               <a:buChar char="▸"/>
             </a:pPr>
             <a:r>
-              <a:rPr lang="en-US" sz="1600" dirty="0">
+              <a:rPr lang="en-US" sz="2000" dirty="0">
                 <a:solidFill>
                   <a:srgbClr val="CBD5E1"/>
                 </a:solidFill>
@@ -5108,7 +5110,7 @@
               </a:rPr>
               <a:t>Clear roles, shared context, honest evidence, and visible decisions transfer to any workflow.</a:t>
             </a:r>
-            <a:endParaRPr lang="en-US" sz="1600" dirty="0"/>
+            <a:endParaRPr lang="en-US" sz="2000" dirty="0"/>
           </a:p>
           <a:p>
             <a:pPr marL="342900" indent="-342900">
@@ -5122,7 +5124,7 @@
               <a:buChar char="▸"/>
             </a:pPr>
             <a:r>
-              <a:rPr lang="en-US" sz="1600" dirty="0">
+              <a:rPr lang="en-US" sz="2000" dirty="0">
                 <a:solidFill>
                   <a:srgbClr val="CBD5E1"/>
                 </a:solidFill>
@@ -5132,7 +5134,7 @@
               </a:rPr>
               <a:t>The technology is the easy half; the operating model is the durable part.</a:t>
             </a:r>
-            <a:endParaRPr lang="en-US" sz="1600" dirty="0"/>
+            <a:endParaRPr lang="en-US" sz="2000" dirty="0"/>
           </a:p>
           <a:p>
             <a:pPr marL="342900" indent="-342900">
@@ -5146,7 +5148,7 @@
               <a:buChar char="▸"/>
             </a:pPr>
             <a:r>
-              <a:rPr lang="en-US" sz="1600" dirty="0">
+              <a:rPr lang="en-US" sz="2000" dirty="0">
                 <a:solidFill>
                   <a:srgbClr val="CBD5E1"/>
                 </a:solidFill>
@@ -5156,7 +5158,7 @@
               </a:rPr>
               <a:t>Hire for people who design protocols first and prompts second.</a:t>
             </a:r>
-            <a:endParaRPr lang="en-US" sz="1600" dirty="0"/>
+            <a:endParaRPr lang="en-US" sz="2000" dirty="0"/>
           </a:p>
         </p:txBody>
       </p:sp>
@@ -5191,8 +5193,8 @@
         </p:nvSpPr>
         <p:spPr>
           <a:xfrm>
-            <a:off x="822960" y="6053328"/>
-            <a:ext cx="9692640" cy="457200"/>
+            <a:off x="822960" y="6035040"/>
+            <a:ext cx="10424160" cy="566928"/>
           </a:xfrm>
           <a:prstGeom prst="rect">
             <a:avLst/>
@@ -5208,9 +5210,9 @@
               <a:buNone/>
             </a:pPr>
             <a:r>
-              <a:rPr lang="en-US" sz="1150" dirty="0">
-                <a:solidFill>
-                  <a:srgbClr val="64748B"/>
+              <a:rPr lang="en-US" sz="1800" dirty="0">
+                <a:solidFill>
+                  <a:srgbClr val="8FA3BF"/>
                 </a:solidFill>
                 <a:latin typeface="Segoe UI" pitchFamily="34" charset="0"/>
                 <a:ea typeface="Segoe UI" pitchFamily="34" charset="-122"/>
@@ -5218,7 +5220,7 @@
               </a:rPr>
               <a:t>Disciplined orchestration beats a smarter chatbot in production.</a:t>
             </a:r>
-            <a:endParaRPr lang="en-US" sz="1150" dirty="0"/>
+            <a:endParaRPr lang="en-US" sz="1800" dirty="0"/>
           </a:p>
         </p:txBody>
       </p:sp>
@@ -5230,8 +5232,8 @@
         </p:nvSpPr>
         <p:spPr>
           <a:xfrm>
-            <a:off x="10698480" y="6382512"/>
-            <a:ext cx="1188720" cy="365760"/>
+            <a:off x="10698480" y="6309360"/>
+            <a:ext cx="1188720" cy="411480"/>
           </a:xfrm>
           <a:prstGeom prst="rect">
             <a:avLst/>
@@ -5247,9 +5249,9 @@
               <a:buNone/>
             </a:pPr>
             <a:r>
-              <a:rPr lang="en-US" sz="1000" dirty="0">
-                <a:solidFill>
-                  <a:srgbClr val="64748B"/>
+              <a:rPr lang="en-US" sz="1800" dirty="0">
+                <a:solidFill>
+                  <a:srgbClr val="8FA3BF"/>
                 </a:solidFill>
                 <a:latin typeface="Consolas" pitchFamily="34" charset="0"/>
                 <a:ea typeface="Consolas" pitchFamily="34" charset="-122"/>
@@ -5257,7 +5259,7 @@
               </a:rPr>
               <a:t>13 / 14</a:t>
             </a:r>
-            <a:endParaRPr lang="en-US" sz="1000" dirty="0"/>
+            <a:endParaRPr lang="en-US" sz="1800" dirty="0"/>
           </a:p>
         </p:txBody>
       </p:sp>
@@ -5341,8 +5343,8 @@
         </p:nvSpPr>
         <p:spPr>
           <a:xfrm>
-            <a:off x="822960" y="1417320"/>
-            <a:ext cx="10515600" cy="411480"/>
+            <a:off x="822960" y="1371600"/>
+            <a:ext cx="10515600" cy="457200"/>
           </a:xfrm>
           <a:prstGeom prst="rect">
             <a:avLst/>
@@ -5358,7 +5360,7 @@
               <a:buNone/>
             </a:pPr>
             <a:r>
-              <a:rPr lang="en-US" sz="1300" spc="400" kern="0" dirty="0">
+              <a:rPr lang="en-US" sz="1800" spc="400" kern="0" dirty="0">
                 <a:solidFill>
                   <a:srgbClr val="06B6D4"/>
                 </a:solidFill>
@@ -5368,7 +5370,7 @@
               </a:rPr>
               <a:t>WORK WITH ME</a:t>
             </a:r>
-            <a:endParaRPr lang="en-US" sz="1300" dirty="0"/>
+            <a:endParaRPr lang="en-US" sz="1800" dirty="0"/>
           </a:p>
         </p:txBody>
       </p:sp>
@@ -5380,7 +5382,7 @@
         </p:nvSpPr>
         <p:spPr>
           <a:xfrm>
-            <a:off x="822960" y="1920240"/>
+            <a:off x="822960" y="1874520"/>
             <a:ext cx="10515600" cy="1371600"/>
           </a:xfrm>
           <a:prstGeom prst="rect">
@@ -5419,8 +5421,8 @@
         </p:nvSpPr>
         <p:spPr>
           <a:xfrm>
-            <a:off x="2011680" y="3429000"/>
-            <a:ext cx="8183880" cy="1554480"/>
+            <a:off x="2011680" y="3383280"/>
+            <a:ext cx="8183880" cy="1691640"/>
           </a:xfrm>
           <a:prstGeom prst="rect">
             <a:avLst/>
@@ -5439,7 +5441,7 @@
               <a:buNone/>
             </a:pPr>
             <a:r>
-              <a:rPr lang="en-US" sz="1500" dirty="0">
+              <a:rPr lang="en-US" sz="2000" dirty="0">
                 <a:solidFill>
                   <a:srgbClr val="CBD5E1"/>
                 </a:solidFill>
@@ -5456,7 +5458,7 @@
               <a:buNone/>
             </a:pPr>
             <a:r>
-              <a:rPr lang="en-US" sz="1500" dirty="0">
+              <a:rPr lang="en-US" sz="2000" dirty="0">
                 <a:solidFill>
                   <a:srgbClr val="CBD5E1"/>
                 </a:solidFill>
@@ -5466,7 +5468,7 @@
               </a:rPr>
               <a:t>Also available for AI automation and data projects worldwide via Upwork.</a:t>
             </a:r>
-            <a:endParaRPr lang="en-US" sz="1500" dirty="0"/>
+            <a:endParaRPr lang="en-US" sz="2000" dirty="0"/>
           </a:p>
         </p:txBody>
       </p:sp>
@@ -5501,8 +5503,8 @@
         </p:nvSpPr>
         <p:spPr>
           <a:xfrm>
-            <a:off x="822960" y="5376672"/>
-            <a:ext cx="10515600" cy="457200"/>
+            <a:off x="822960" y="5349240"/>
+            <a:ext cx="10515600" cy="502920"/>
           </a:xfrm>
           <a:prstGeom prst="rect">
             <a:avLst/>
@@ -5518,7 +5520,7 @@
               <a:buNone/>
             </a:pPr>
             <a:r>
-              <a:rPr lang="en-US" sz="1350" b="1" dirty="0">
+              <a:rPr lang="en-US" sz="1800" b="1" dirty="0">
                 <a:solidFill>
                   <a:srgbClr val="06B6D4"/>
                 </a:solidFill>
@@ -5528,7 +5530,7 @@
               </a:rPr>
               <a:t>rezalianvatiady.github.io · github.com/rezalianvatiady</a:t>
             </a:r>
-            <a:endParaRPr lang="en-US" sz="1350" dirty="0"/>
+            <a:endParaRPr lang="en-US" sz="1800" dirty="0"/>
           </a:p>
         </p:txBody>
       </p:sp>
@@ -5540,8 +5542,8 @@
         </p:nvSpPr>
         <p:spPr>
           <a:xfrm>
-            <a:off x="10698480" y="6382512"/>
-            <a:ext cx="1188720" cy="365760"/>
+            <a:off x="10698480" y="6309360"/>
+            <a:ext cx="1188720" cy="411480"/>
           </a:xfrm>
           <a:prstGeom prst="rect">
             <a:avLst/>
@@ -5557,9 +5559,9 @@
               <a:buNone/>
             </a:pPr>
             <a:r>
-              <a:rPr lang="en-US" sz="1000" dirty="0">
-                <a:solidFill>
-                  <a:srgbClr val="64748B"/>
+              <a:rPr lang="en-US" sz="1800" dirty="0">
+                <a:solidFill>
+                  <a:srgbClr val="8FA3BF"/>
                 </a:solidFill>
                 <a:latin typeface="Consolas" pitchFamily="34" charset="0"/>
                 <a:ea typeface="Consolas" pitchFamily="34" charset="-122"/>
@@ -5567,7 +5569,7 @@
               </a:rPr>
               <a:t>14 / 14</a:t>
             </a:r>
-            <a:endParaRPr lang="en-US" sz="1000" dirty="0"/>
+            <a:endParaRPr lang="en-US" sz="1800" dirty="0"/>
           </a:p>
         </p:txBody>
       </p:sp>
@@ -5651,8 +5653,8 @@
         </p:nvSpPr>
         <p:spPr>
           <a:xfrm>
-            <a:off x="822960" y="502920"/>
-            <a:ext cx="10515600" cy="365760"/>
+            <a:off x="822960" y="457200"/>
+            <a:ext cx="10515600" cy="411480"/>
           </a:xfrm>
           <a:prstGeom prst="rect">
             <a:avLst/>
@@ -5668,7 +5670,7 @@
               <a:buNone/>
             </a:pPr>
             <a:r>
-              <a:rPr lang="en-US" sz="1200" spc="300" kern="0" dirty="0">
+              <a:rPr lang="en-US" sz="1800" spc="300" kern="0" dirty="0">
                 <a:solidFill>
                   <a:srgbClr val="06B6D4"/>
                 </a:solidFill>
@@ -5678,7 +5680,7 @@
               </a:rPr>
               <a:t>AGENDA</a:t>
             </a:r>
-            <a:endParaRPr lang="en-US" sz="1200" dirty="0"/>
+            <a:endParaRPr lang="en-US" sz="1800" dirty="0"/>
           </a:p>
         </p:txBody>
       </p:sp>
@@ -5729,8 +5731,8 @@
         </p:nvSpPr>
         <p:spPr>
           <a:xfrm>
-            <a:off x="868680" y="2112264"/>
-            <a:ext cx="420624" cy="420624"/>
+            <a:off x="868680" y="2103120"/>
+            <a:ext cx="457200" cy="457200"/>
           </a:xfrm>
           <a:prstGeom prst="ellipse">
             <a:avLst/>
@@ -5754,8 +5756,8 @@
         </p:nvSpPr>
         <p:spPr>
           <a:xfrm>
-            <a:off x="868680" y="2112264"/>
-            <a:ext cx="420624" cy="420624"/>
+            <a:off x="868680" y="2103120"/>
+            <a:ext cx="457200" cy="457200"/>
           </a:xfrm>
           <a:prstGeom prst="rect">
             <a:avLst/>
@@ -5771,7 +5773,7 @@
               <a:buNone/>
             </a:pPr>
             <a:r>
-              <a:rPr lang="en-US" sz="1300" b="1" dirty="0">
+              <a:rPr lang="en-US" sz="1800" b="1" dirty="0">
                 <a:solidFill>
                   <a:srgbClr val="3B82F6"/>
                 </a:solidFill>
@@ -5781,7 +5783,7 @@
               </a:rPr>
               <a:t>1</a:t>
             </a:r>
-            <a:endParaRPr lang="en-US" sz="1300" dirty="0"/>
+            <a:endParaRPr lang="en-US" sz="1800" dirty="0"/>
           </a:p>
         </p:txBody>
       </p:sp>
@@ -5793,8 +5795,8 @@
         </p:nvSpPr>
         <p:spPr>
           <a:xfrm>
-            <a:off x="1435608" y="2057400"/>
-            <a:ext cx="4480560" cy="822960"/>
+            <a:off x="1472184" y="2011680"/>
+            <a:ext cx="4443984" cy="960120"/>
           </a:xfrm>
           <a:prstGeom prst="rect">
             <a:avLst/>
@@ -5810,7 +5812,7 @@
               <a:buNone/>
             </a:pPr>
             <a:r>
-              <a:rPr lang="en-US" sz="1450" dirty="0">
+              <a:rPr lang="en-US" sz="2000" dirty="0">
                 <a:solidFill>
                   <a:srgbClr val="CBD5E1"/>
                 </a:solidFill>
@@ -5820,7 +5822,7 @@
               </a:rPr>
               <a:t>Nine agents, nine mandates: the role map</a:t>
             </a:r>
-            <a:endParaRPr lang="en-US" sz="1450" dirty="0"/>
+            <a:endParaRPr lang="en-US" sz="2000" dirty="0"/>
           </a:p>
         </p:txBody>
       </p:sp>
@@ -5832,8 +5834,8 @@
         </p:nvSpPr>
         <p:spPr>
           <a:xfrm>
-            <a:off x="868680" y="3044952"/>
-            <a:ext cx="420624" cy="420624"/>
+            <a:off x="868680" y="3182112"/>
+            <a:ext cx="457200" cy="457200"/>
           </a:xfrm>
           <a:prstGeom prst="ellipse">
             <a:avLst/>
@@ -5857,8 +5859,8 @@
         </p:nvSpPr>
         <p:spPr>
           <a:xfrm>
-            <a:off x="868680" y="3044952"/>
-            <a:ext cx="420624" cy="420624"/>
+            <a:off x="868680" y="3182112"/>
+            <a:ext cx="457200" cy="457200"/>
           </a:xfrm>
           <a:prstGeom prst="rect">
             <a:avLst/>
@@ -5874,7 +5876,7 @@
               <a:buNone/>
             </a:pPr>
             <a:r>
-              <a:rPr lang="en-US" sz="1300" b="1" dirty="0">
+              <a:rPr lang="en-US" sz="1800" b="1" dirty="0">
                 <a:solidFill>
                   <a:srgbClr val="06B6D4"/>
                 </a:solidFill>
@@ -5884,7 +5886,7 @@
               </a:rPr>
               <a:t>2</a:t>
             </a:r>
-            <a:endParaRPr lang="en-US" sz="1300" dirty="0"/>
+            <a:endParaRPr lang="en-US" sz="1800" dirty="0"/>
           </a:p>
         </p:txBody>
       </p:sp>
@@ -5896,8 +5898,8 @@
         </p:nvSpPr>
         <p:spPr>
           <a:xfrm>
-            <a:off x="1435608" y="2990088"/>
-            <a:ext cx="4480560" cy="822960"/>
+            <a:off x="1472184" y="3090672"/>
+            <a:ext cx="4443984" cy="960120"/>
           </a:xfrm>
           <a:prstGeom prst="rect">
             <a:avLst/>
@@ -5913,7 +5915,7 @@
               <a:buNone/>
             </a:pPr>
             <a:r>
-              <a:rPr lang="en-US" sz="1450" dirty="0">
+              <a:rPr lang="en-US" sz="2000" dirty="0">
                 <a:solidFill>
                   <a:srgbClr val="CBD5E1"/>
                 </a:solidFill>
@@ -5923,7 +5925,7 @@
               </a:rPr>
               <a:t>The protocols: memory, evidence, rooms, queues</a:t>
             </a:r>
-            <a:endParaRPr lang="en-US" sz="1450" dirty="0"/>
+            <a:endParaRPr lang="en-US" sz="2000" dirty="0"/>
           </a:p>
         </p:txBody>
       </p:sp>
@@ -5935,8 +5937,8 @@
         </p:nvSpPr>
         <p:spPr>
           <a:xfrm>
-            <a:off x="868680" y="3977640"/>
-            <a:ext cx="420624" cy="420624"/>
+            <a:off x="868680" y="4261104"/>
+            <a:ext cx="457200" cy="457200"/>
           </a:xfrm>
           <a:prstGeom prst="ellipse">
             <a:avLst/>
@@ -5960,8 +5962,8 @@
         </p:nvSpPr>
         <p:spPr>
           <a:xfrm>
-            <a:off x="868680" y="3977640"/>
-            <a:ext cx="420624" cy="420624"/>
+            <a:off x="868680" y="4261104"/>
+            <a:ext cx="457200" cy="457200"/>
           </a:xfrm>
           <a:prstGeom prst="rect">
             <a:avLst/>
@@ -5977,7 +5979,7 @@
               <a:buNone/>
             </a:pPr>
             <a:r>
-              <a:rPr lang="en-US" sz="1300" b="1" dirty="0">
+              <a:rPr lang="en-US" sz="1800" b="1" dirty="0">
                 <a:solidFill>
                   <a:srgbClr val="3B82F6"/>
                 </a:solidFill>
@@ -5987,7 +5989,7 @@
               </a:rPr>
               <a:t>3</a:t>
             </a:r>
-            <a:endParaRPr lang="en-US" sz="1300" dirty="0"/>
+            <a:endParaRPr lang="en-US" sz="1800" dirty="0"/>
           </a:p>
         </p:txBody>
       </p:sp>
@@ -5999,8 +6001,8 @@
         </p:nvSpPr>
         <p:spPr>
           <a:xfrm>
-            <a:off x="1435608" y="3922776"/>
-            <a:ext cx="4480560" cy="822960"/>
+            <a:off x="1472184" y="4169664"/>
+            <a:ext cx="4443984" cy="960120"/>
           </a:xfrm>
           <a:prstGeom prst="rect">
             <a:avLst/>
@@ -6016,7 +6018,7 @@
               <a:buNone/>
             </a:pPr>
             <a:r>
-              <a:rPr lang="en-US" sz="1450" dirty="0">
+              <a:rPr lang="en-US" sz="2000" dirty="0">
                 <a:solidFill>
                   <a:srgbClr val="CBD5E1"/>
                 </a:solidFill>
@@ -6026,7 +6028,7 @@
               </a:rPr>
               <a:t>The request lifecycle, from brief to approval</a:t>
             </a:r>
-            <a:endParaRPr lang="en-US" sz="1450" dirty="0"/>
+            <a:endParaRPr lang="en-US" sz="2000" dirty="0"/>
           </a:p>
         </p:txBody>
       </p:sp>
@@ -6038,8 +6040,8 @@
         </p:nvSpPr>
         <p:spPr>
           <a:xfrm>
-            <a:off x="6355080" y="2112264"/>
-            <a:ext cx="420624" cy="420624"/>
+            <a:off x="6355080" y="2103120"/>
+            <a:ext cx="457200" cy="457200"/>
           </a:xfrm>
           <a:prstGeom prst="ellipse">
             <a:avLst/>
@@ -6063,8 +6065,8 @@
         </p:nvSpPr>
         <p:spPr>
           <a:xfrm>
-            <a:off x="6355080" y="2112264"/>
-            <a:ext cx="420624" cy="420624"/>
+            <a:off x="6355080" y="2103120"/>
+            <a:ext cx="457200" cy="457200"/>
           </a:xfrm>
           <a:prstGeom prst="rect">
             <a:avLst/>
@@ -6080,7 +6082,7 @@
               <a:buNone/>
             </a:pPr>
             <a:r>
-              <a:rPr lang="en-US" sz="1300" b="1" dirty="0">
+              <a:rPr lang="en-US" sz="1800" b="1" dirty="0">
                 <a:solidFill>
                   <a:srgbClr val="06B6D4"/>
                 </a:solidFill>
@@ -6090,7 +6092,7 @@
               </a:rPr>
               <a:t>4</a:t>
             </a:r>
-            <a:endParaRPr lang="en-US" sz="1300" dirty="0"/>
+            <a:endParaRPr lang="en-US" sz="1800" dirty="0"/>
           </a:p>
         </p:txBody>
       </p:sp>
@@ -6102,8 +6104,8 @@
         </p:nvSpPr>
         <p:spPr>
           <a:xfrm>
-            <a:off x="6922008" y="2057400"/>
-            <a:ext cx="4480560" cy="822960"/>
+            <a:off x="6958584" y="2011680"/>
+            <a:ext cx="4443984" cy="960120"/>
           </a:xfrm>
           <a:prstGeom prst="rect">
             <a:avLst/>
@@ -6119,7 +6121,7 @@
               <a:buNone/>
             </a:pPr>
             <a:r>
-              <a:rPr lang="en-US" sz="1450" dirty="0">
+              <a:rPr lang="en-US" sz="2000" dirty="0">
                 <a:solidFill>
                   <a:srgbClr val="CBD5E1"/>
                 </a:solidFill>
@@ -6129,7 +6131,7 @@
               </a:rPr>
               <a:t>The numbers: routing accuracy, checks, zero self-approvals</a:t>
             </a:r>
-            <a:endParaRPr lang="en-US" sz="1450" dirty="0"/>
+            <a:endParaRPr lang="en-US" sz="2000" dirty="0"/>
           </a:p>
         </p:txBody>
       </p:sp>
@@ -6141,8 +6143,8 @@
         </p:nvSpPr>
         <p:spPr>
           <a:xfrm>
-            <a:off x="6355080" y="3044952"/>
-            <a:ext cx="420624" cy="420624"/>
+            <a:off x="6355080" y="3182112"/>
+            <a:ext cx="457200" cy="457200"/>
           </a:xfrm>
           <a:prstGeom prst="ellipse">
             <a:avLst/>
@@ -6166,8 +6168,8 @@
         </p:nvSpPr>
         <p:spPr>
           <a:xfrm>
-            <a:off x="6355080" y="3044952"/>
-            <a:ext cx="420624" cy="420624"/>
+            <a:off x="6355080" y="3182112"/>
+            <a:ext cx="457200" cy="457200"/>
           </a:xfrm>
           <a:prstGeom prst="rect">
             <a:avLst/>
@@ -6183,7 +6185,7 @@
               <a:buNone/>
             </a:pPr>
             <a:r>
-              <a:rPr lang="en-US" sz="1300" b="1" dirty="0">
+              <a:rPr lang="en-US" sz="1800" b="1" dirty="0">
                 <a:solidFill>
                   <a:srgbClr val="3B82F6"/>
                 </a:solidFill>
@@ -6193,7 +6195,7 @@
               </a:rPr>
               <a:t>5</a:t>
             </a:r>
-            <a:endParaRPr lang="en-US" sz="1300" dirty="0"/>
+            <a:endParaRPr lang="en-US" sz="1800" dirty="0"/>
           </a:p>
         </p:txBody>
       </p:sp>
@@ -6205,8 +6207,8 @@
         </p:nvSpPr>
         <p:spPr>
           <a:xfrm>
-            <a:off x="6922008" y="2990088"/>
-            <a:ext cx="4480560" cy="822960"/>
+            <a:off x="6958584" y="3090672"/>
+            <a:ext cx="4443984" cy="960120"/>
           </a:xfrm>
           <a:prstGeom prst="rect">
             <a:avLst/>
@@ -6222,7 +6224,7 @@
               <a:buNone/>
             </a:pPr>
             <a:r>
-              <a:rPr lang="en-US" sz="1450" dirty="0">
+              <a:rPr lang="en-US" sz="2000" dirty="0">
                 <a:solidFill>
                   <a:srgbClr val="CBD5E1"/>
                 </a:solidFill>
@@ -6232,7 +6234,7 @@
               </a:rPr>
               <a:t>Division of labor: what agents own vs what the human owns</a:t>
             </a:r>
-            <a:endParaRPr lang="en-US" sz="1450" dirty="0"/>
+            <a:endParaRPr lang="en-US" sz="2000" dirty="0"/>
           </a:p>
         </p:txBody>
       </p:sp>
@@ -6244,8 +6246,8 @@
         </p:nvSpPr>
         <p:spPr>
           <a:xfrm>
-            <a:off x="6355080" y="3977640"/>
-            <a:ext cx="420624" cy="420624"/>
+            <a:off x="6355080" y="4261104"/>
+            <a:ext cx="457200" cy="457200"/>
           </a:xfrm>
           <a:prstGeom prst="ellipse">
             <a:avLst/>
@@ -6269,8 +6271,8 @@
         </p:nvSpPr>
         <p:spPr>
           <a:xfrm>
-            <a:off x="6355080" y="3977640"/>
-            <a:ext cx="420624" cy="420624"/>
+            <a:off x="6355080" y="4261104"/>
+            <a:ext cx="457200" cy="457200"/>
           </a:xfrm>
           <a:prstGeom prst="rect">
             <a:avLst/>
@@ -6286,7 +6288,7 @@
               <a:buNone/>
             </a:pPr>
             <a:r>
-              <a:rPr lang="en-US" sz="1300" b="1" dirty="0">
+              <a:rPr lang="en-US" sz="1800" b="1" dirty="0">
                 <a:solidFill>
                   <a:srgbClr val="06B6D4"/>
                 </a:solidFill>
@@ -6296,7 +6298,7 @@
               </a:rPr>
               <a:t>6</a:t>
             </a:r>
-            <a:endParaRPr lang="en-US" sz="1300" dirty="0"/>
+            <a:endParaRPr lang="en-US" sz="1800" dirty="0"/>
           </a:p>
         </p:txBody>
       </p:sp>
@@ -6308,8 +6310,8 @@
         </p:nvSpPr>
         <p:spPr>
           <a:xfrm>
-            <a:off x="6922008" y="3922776"/>
-            <a:ext cx="4480560" cy="822960"/>
+            <a:off x="6958584" y="4169664"/>
+            <a:ext cx="4443984" cy="960120"/>
           </a:xfrm>
           <a:prstGeom prst="rect">
             <a:avLst/>
@@ -6325,7 +6327,7 @@
               <a:buNone/>
             </a:pPr>
             <a:r>
-              <a:rPr lang="en-US" sz="1450" dirty="0">
+              <a:rPr lang="en-US" sz="2000" dirty="0">
                 <a:solidFill>
                   <a:srgbClr val="CBD5E1"/>
                 </a:solidFill>
@@ -6335,7 +6337,7 @@
               </a:rPr>
               <a:t>Failure handling: watchdog, honest red status, written lessons</a:t>
             </a:r>
-            <a:endParaRPr lang="en-US" sz="1450" dirty="0"/>
+            <a:endParaRPr lang="en-US" sz="2000" dirty="0"/>
           </a:p>
         </p:txBody>
       </p:sp>
@@ -6347,8 +6349,8 @@
         </p:nvSpPr>
         <p:spPr>
           <a:xfrm>
-            <a:off x="10698480" y="6382512"/>
-            <a:ext cx="1188720" cy="365760"/>
+            <a:off x="10698480" y="6309360"/>
+            <a:ext cx="1188720" cy="411480"/>
           </a:xfrm>
           <a:prstGeom prst="rect">
             <a:avLst/>
@@ -6364,9 +6366,9 @@
               <a:buNone/>
             </a:pPr>
             <a:r>
-              <a:rPr lang="en-US" sz="1000" dirty="0">
-                <a:solidFill>
-                  <a:srgbClr val="64748B"/>
+              <a:rPr lang="en-US" sz="1800" dirty="0">
+                <a:solidFill>
+                  <a:srgbClr val="8FA3BF"/>
                 </a:solidFill>
                 <a:latin typeface="Consolas" pitchFamily="34" charset="0"/>
                 <a:ea typeface="Consolas" pitchFamily="34" charset="-122"/>
@@ -6374,7 +6376,7 @@
               </a:rPr>
               <a:t>2 / 14</a:t>
             </a:r>
-            <a:endParaRPr lang="en-US" sz="1000" dirty="0"/>
+            <a:endParaRPr lang="en-US" sz="1800" dirty="0"/>
           </a:p>
         </p:txBody>
       </p:sp>
@@ -6458,8 +6460,8 @@
         </p:nvSpPr>
         <p:spPr>
           <a:xfrm>
-            <a:off x="822960" y="502920"/>
-            <a:ext cx="10515600" cy="365760"/>
+            <a:off x="822960" y="457200"/>
+            <a:ext cx="10515600" cy="411480"/>
           </a:xfrm>
           <a:prstGeom prst="rect">
             <a:avLst/>
@@ -6475,7 +6477,7 @@
               <a:buNone/>
             </a:pPr>
             <a:r>
-              <a:rPr lang="en-US" sz="1200" spc="300" kern="0" dirty="0">
+              <a:rPr lang="en-US" sz="1800" spc="300" kern="0" dirty="0">
                 <a:solidFill>
                   <a:srgbClr val="06B6D4"/>
                 </a:solidFill>
@@ -6485,7 +6487,7 @@
               </a:rPr>
               <a:t>ROLES</a:t>
             </a:r>
-            <a:endParaRPr lang="en-US" sz="1200" dirty="0"/>
+            <a:endParaRPr lang="en-US" sz="1800" dirty="0"/>
           </a:p>
         </p:txBody>
       </p:sp>
@@ -6536,8 +6538,8 @@
         </p:nvSpPr>
         <p:spPr>
           <a:xfrm>
-            <a:off x="868680" y="2011680"/>
-            <a:ext cx="10424160" cy="3566160"/>
+            <a:off x="868680" y="1965960"/>
+            <a:ext cx="10424160" cy="3840480"/>
           </a:xfrm>
           <a:prstGeom prst="rect">
             <a:avLst/>
@@ -6560,7 +6562,7 @@
               <a:buChar char="▸"/>
             </a:pPr>
             <a:r>
-              <a:rPr lang="en-US" sz="1600" dirty="0">
+              <a:rPr lang="en-US" sz="2000" dirty="0">
                 <a:solidFill>
                   <a:srgbClr val="CBD5E1"/>
                 </a:solidFill>
@@ -6570,7 +6572,7 @@
               </a:rPr>
               <a:t>Engineering agents build and maintain apps end-to-end, from spec to shipped build.</a:t>
             </a:r>
-            <a:endParaRPr lang="en-US" sz="1600" dirty="0"/>
+            <a:endParaRPr lang="en-US" sz="2000" dirty="0"/>
           </a:p>
           <a:p>
             <a:pPr marL="342900" indent="-342900">
@@ -6584,7 +6586,7 @@
               <a:buChar char="▸"/>
             </a:pPr>
             <a:r>
-              <a:rPr lang="en-US" sz="1600" dirty="0">
+              <a:rPr lang="en-US" sz="2000" dirty="0">
                 <a:solidFill>
                   <a:srgbClr val="CBD5E1"/>
                 </a:solidFill>
@@ -6594,7 +6596,7 @@
               </a:rPr>
               <a:t>The QA agent owns the release gate and can stop the line; the PM agent tracks status, priorities, and pending decisions.</a:t>
             </a:r>
-            <a:endParaRPr lang="en-US" sz="1600" dirty="0"/>
+            <a:endParaRPr lang="en-US" sz="2000" dirty="0"/>
           </a:p>
           <a:p>
             <a:pPr marL="342900" indent="-342900">
@@ -6608,7 +6610,7 @@
               <a:buChar char="▸"/>
             </a:pPr>
             <a:r>
-              <a:rPr lang="en-US" sz="1600" dirty="0">
+              <a:rPr lang="en-US" sz="2000" dirty="0">
                 <a:solidFill>
                   <a:srgbClr val="CBD5E1"/>
                 </a:solidFill>
@@ -6618,7 +6620,7 @@
               </a:rPr>
               <a:t>The docs agent keeps every rule, decision, and lesson written down, so the company never forgets.</a:t>
             </a:r>
-            <a:endParaRPr lang="en-US" sz="1600" dirty="0"/>
+            <a:endParaRPr lang="en-US" sz="2000" dirty="0"/>
           </a:p>
           <a:p>
             <a:pPr marL="342900" indent="-342900">
@@ -6632,7 +6634,7 @@
               <a:buChar char="▸"/>
             </a:pPr>
             <a:r>
-              <a:rPr lang="en-US" sz="1600" dirty="0">
+              <a:rPr lang="en-US" sz="2000" dirty="0">
                 <a:solidFill>
                   <a:srgbClr val="CBD5E1"/>
                 </a:solidFill>
@@ -6642,7 +6644,7 @@
               </a:rPr>
               <a:t>The secretary agent runs portfolio, presentations, and content; specialists cover data, GIS, OSINT, and system watching.</a:t>
             </a:r>
-            <a:endParaRPr lang="en-US" sz="1600" dirty="0"/>
+            <a:endParaRPr lang="en-US" sz="2000" dirty="0"/>
           </a:p>
         </p:txBody>
       </p:sp>
@@ -6677,8 +6679,8 @@
         </p:nvSpPr>
         <p:spPr>
           <a:xfrm>
-            <a:off x="822960" y="6053328"/>
-            <a:ext cx="9692640" cy="457200"/>
+            <a:off x="822960" y="6035040"/>
+            <a:ext cx="10424160" cy="566928"/>
           </a:xfrm>
           <a:prstGeom prst="rect">
             <a:avLst/>
@@ -6694,9 +6696,9 @@
               <a:buNone/>
             </a:pPr>
             <a:r>
-              <a:rPr lang="en-US" sz="1150" dirty="0">
-                <a:solidFill>
-                  <a:srgbClr val="64748B"/>
+              <a:rPr lang="en-US" sz="1800" dirty="0">
+                <a:solidFill>
+                  <a:srgbClr val="8FA3BF"/>
                 </a:solidFill>
                 <a:latin typeface="Segoe UI" pitchFamily="34" charset="0"/>
                 <a:ea typeface="Segoe UI" pitchFamily="34" charset="-122"/>
@@ -6704,7 +6706,7 @@
               </a:rPr>
               <a:t>Every mandate is scoped; a generalist that attempts everything owns nothing.</a:t>
             </a:r>
-            <a:endParaRPr lang="en-US" sz="1150" dirty="0"/>
+            <a:endParaRPr lang="en-US" sz="1800" dirty="0"/>
           </a:p>
         </p:txBody>
       </p:sp>
@@ -6716,8 +6718,8 @@
         </p:nvSpPr>
         <p:spPr>
           <a:xfrm>
-            <a:off x="10698480" y="6382512"/>
-            <a:ext cx="1188720" cy="365760"/>
+            <a:off x="10698480" y="6309360"/>
+            <a:ext cx="1188720" cy="411480"/>
           </a:xfrm>
           <a:prstGeom prst="rect">
             <a:avLst/>
@@ -6733,9 +6735,9 @@
               <a:buNone/>
             </a:pPr>
             <a:r>
-              <a:rPr lang="en-US" sz="1000" dirty="0">
-                <a:solidFill>
-                  <a:srgbClr val="64748B"/>
+              <a:rPr lang="en-US" sz="1800" dirty="0">
+                <a:solidFill>
+                  <a:srgbClr val="8FA3BF"/>
                 </a:solidFill>
                 <a:latin typeface="Consolas" pitchFamily="34" charset="0"/>
                 <a:ea typeface="Consolas" pitchFamily="34" charset="-122"/>
@@ -6743,7 +6745,7 @@
               </a:rPr>
               <a:t>3 / 14</a:t>
             </a:r>
-            <a:endParaRPr lang="en-US" sz="1000" dirty="0"/>
+            <a:endParaRPr lang="en-US" sz="1800" dirty="0"/>
           </a:p>
         </p:txBody>
       </p:sp>
@@ -6827,8 +6829,8 @@
         </p:nvSpPr>
         <p:spPr>
           <a:xfrm>
-            <a:off x="822960" y="502920"/>
-            <a:ext cx="10515600" cy="365760"/>
+            <a:off x="822960" y="457200"/>
+            <a:ext cx="10515600" cy="411480"/>
           </a:xfrm>
           <a:prstGeom prst="rect">
             <a:avLst/>
@@ -6844,7 +6846,7 @@
               <a:buNone/>
             </a:pPr>
             <a:r>
-              <a:rPr lang="en-US" sz="1200" spc="300" kern="0" dirty="0">
+              <a:rPr lang="en-US" sz="1800" spc="300" kern="0" dirty="0">
                 <a:solidFill>
                   <a:srgbClr val="06B6D4"/>
                 </a:solidFill>
@@ -6854,7 +6856,7 @@
               </a:rPr>
               <a:t>ROLE MAP</a:t>
             </a:r>
-            <a:endParaRPr lang="en-US" sz="1200" dirty="0"/>
+            <a:endParaRPr lang="en-US" sz="1800" dirty="0"/>
           </a:p>
         </p:txBody>
       </p:sp>
@@ -6912,7 +6914,7 @@
           </p:nvPr>
         </p:nvGraphicFramePr>
         <p:xfrm>
-          <a:off x="822960" y="2011680"/>
+          <a:off x="822960" y="1828800"/>
           <a:ext cx="10515600" cy="914400"/>
         </p:xfrm>
         <a:graphic>
@@ -6924,7 +6926,7 @@
                 <a:gridCol w="3505200"/>
                 <a:gridCol w="3505200"/>
               </a:tblGrid>
-              <a:tr h="402336">
+              <a:tr h="457200">
                 <a:tc>
                   <a:txBody>
                     <a:bodyPr/>
@@ -6934,7 +6936,7 @@
                         <a:buNone/>
                       </a:pPr>
                       <a:r>
-                        <a:rPr lang="en-US" sz="1150" b="1" dirty="0">
+                        <a:rPr lang="en-US" sz="1800" b="1" dirty="0">
                           <a:solidFill>
                             <a:srgbClr val="FFFFFF"/>
                           </a:solidFill>
@@ -6944,14 +6946,14 @@
                         </a:rPr>
                         <a:t>Agent</a:t>
                       </a:r>
-                      <a:endParaRPr lang="en-US" sz="1150" dirty="0">
+                      <a:endParaRPr lang="en-US" sz="1800" dirty="0">
                         <a:latin typeface="Segoe UI" charset="0"/>
                         <a:ea typeface="Segoe UI" charset="0"/>
                         <a:cs typeface="Segoe UI" charset="0"/>
                       </a:endParaRPr>
                     </a:p>
                   </a:txBody>
-                  <a:tcPr marL="64008" marR="64008" marT="64008" marB="64008" anchor="ctr">
+                  <a:tcPr marL="36576" marR="36576" marT="36576" marB="36576" anchor="ctr">
                     <a:lnL w="6350" cap="flat" cmpd="sng" algn="ctr">
                       <a:solidFill>
                         <a:srgbClr val="24365A"/>
@@ -7002,7 +7004,7 @@
                         <a:buNone/>
                       </a:pPr>
                       <a:r>
-                        <a:rPr lang="en-US" sz="1150" b="1" dirty="0">
+                        <a:rPr lang="en-US" sz="1800" b="1" dirty="0">
                           <a:solidFill>
                             <a:srgbClr val="FFFFFF"/>
                           </a:solidFill>
@@ -7012,14 +7014,14 @@
                         </a:rPr>
                         <a:t>Mandate</a:t>
                       </a:r>
-                      <a:endParaRPr lang="en-US" sz="1150" dirty="0">
+                      <a:endParaRPr lang="en-US" sz="1800" dirty="0">
                         <a:latin typeface="Segoe UI" charset="0"/>
                         <a:ea typeface="Segoe UI" charset="0"/>
                         <a:cs typeface="Segoe UI" charset="0"/>
                       </a:endParaRPr>
                     </a:p>
                   </a:txBody>
-                  <a:tcPr marL="64008" marR="64008" marT="64008" marB="64008" anchor="ctr">
+                  <a:tcPr marL="36576" marR="36576" marT="36576" marB="36576" anchor="ctr">
                     <a:lnL w="6350" cap="flat" cmpd="sng" algn="ctr">
                       <a:solidFill>
                         <a:srgbClr val="24365A"/>
@@ -7070,7 +7072,7 @@
                         <a:buNone/>
                       </a:pPr>
                       <a:r>
-                        <a:rPr lang="en-US" sz="1150" b="1" dirty="0">
+                        <a:rPr lang="en-US" sz="1800" b="1" dirty="0">
                           <a:solidFill>
                             <a:srgbClr val="FFFFFF"/>
                           </a:solidFill>
@@ -7080,14 +7082,14 @@
                         </a:rPr>
                         <a:t>Guardrail</a:t>
                       </a:r>
-                      <a:endParaRPr lang="en-US" sz="1150" dirty="0">
+                      <a:endParaRPr lang="en-US" sz="1800" dirty="0">
                         <a:latin typeface="Segoe UI" charset="0"/>
                         <a:ea typeface="Segoe UI" charset="0"/>
                         <a:cs typeface="Segoe UI" charset="0"/>
                       </a:endParaRPr>
                     </a:p>
                   </a:txBody>
-                  <a:tcPr marL="64008" marR="64008" marT="64008" marB="64008" anchor="ctr">
+                  <a:tcPr marL="36576" marR="36576" marT="36576" marB="36576" anchor="ctr">
                     <a:lnL w="6350" cap="flat" cmpd="sng" algn="ctr">
                       <a:solidFill>
                         <a:srgbClr val="24365A"/>
@@ -7130,7 +7132,7 @@
                   </a:tcPr>
                 </a:tc>
               </a:tr>
-              <a:tr h="402336">
+              <a:tr h="457200">
                 <a:tc>
                   <a:txBody>
                     <a:bodyPr/>
@@ -7140,7 +7142,7 @@
                         <a:buNone/>
                       </a:pPr>
                       <a:r>
-                        <a:rPr lang="en-US" sz="1080" dirty="0">
+                        <a:rPr lang="en-US" sz="1800" dirty="0">
                           <a:solidFill>
                             <a:srgbClr val="CBD5E1"/>
                           </a:solidFill>
@@ -7150,14 +7152,14 @@
                         </a:rPr>
                         <a:t>Engineering</a:t>
                       </a:r>
-                      <a:endParaRPr lang="en-US" sz="1080" dirty="0">
+                      <a:endParaRPr lang="en-US" sz="1800" dirty="0">
                         <a:latin typeface="Segoe UI" charset="0"/>
                         <a:ea typeface="Segoe UI" charset="0"/>
                         <a:cs typeface="Segoe UI" charset="0"/>
                       </a:endParaRPr>
                     </a:p>
                   </a:txBody>
-                  <a:tcPr marL="64008" marR="64008" marT="64008" marB="64008" anchor="ctr">
+                  <a:tcPr marL="36576" marR="36576" marT="36576" marB="36576" anchor="ctr">
                     <a:lnL w="6350" cap="flat" cmpd="sng" algn="ctr">
                       <a:solidFill>
                         <a:srgbClr val="24365A"/>
@@ -7208,7 +7210,7 @@
                         <a:buNone/>
                       </a:pPr>
                       <a:r>
-                        <a:rPr lang="en-US" sz="1080" dirty="0">
+                        <a:rPr lang="en-US" sz="1800" dirty="0">
                           <a:solidFill>
                             <a:srgbClr val="CBD5E1"/>
                           </a:solidFill>
@@ -7218,14 +7220,14 @@
                         </a:rPr>
                         <a:t>Build and maintain apps end-to-end</a:t>
                       </a:r>
-                      <a:endParaRPr lang="en-US" sz="1080" dirty="0">
+                      <a:endParaRPr lang="en-US" sz="1800" dirty="0">
                         <a:latin typeface="Segoe UI" charset="0"/>
                         <a:ea typeface="Segoe UI" charset="0"/>
                         <a:cs typeface="Segoe UI" charset="0"/>
                       </a:endParaRPr>
                     </a:p>
                   </a:txBody>
-                  <a:tcPr marL="64008" marR="64008" marT="64008" marB="64008" anchor="ctr">
+                  <a:tcPr marL="36576" marR="36576" marT="36576" marB="36576" anchor="ctr">
                     <a:lnL w="6350" cap="flat" cmpd="sng" algn="ctr">
                       <a:solidFill>
                         <a:srgbClr val="24365A"/>
@@ -7276,7 +7278,7 @@
                         <a:buNone/>
                       </a:pPr>
                       <a:r>
-                        <a:rPr lang="en-US" sz="1080" dirty="0">
+                        <a:rPr lang="en-US" sz="1800" dirty="0">
                           <a:solidFill>
                             <a:srgbClr val="CBD5E1"/>
                           </a:solidFill>
@@ -7286,14 +7288,14 @@
                         </a:rPr>
                         <a:t>Ships only through the quality gate</a:t>
                       </a:r>
-                      <a:endParaRPr lang="en-US" sz="1080" dirty="0">
+                      <a:endParaRPr lang="en-US" sz="1800" dirty="0">
                         <a:latin typeface="Segoe UI" charset="0"/>
                         <a:ea typeface="Segoe UI" charset="0"/>
                         <a:cs typeface="Segoe UI" charset="0"/>
                       </a:endParaRPr>
                     </a:p>
                   </a:txBody>
-                  <a:tcPr marL="64008" marR="64008" marT="64008" marB="64008" anchor="ctr">
+                  <a:tcPr marL="36576" marR="36576" marT="36576" marB="36576" anchor="ctr">
                     <a:lnL w="6350" cap="flat" cmpd="sng" algn="ctr">
                       <a:solidFill>
                         <a:srgbClr val="24365A"/>
@@ -7336,7 +7338,7 @@
                   </a:tcPr>
                 </a:tc>
               </a:tr>
-              <a:tr h="402336">
+              <a:tr h="457200">
                 <a:tc>
                   <a:txBody>
                     <a:bodyPr/>
@@ -7346,7 +7348,7 @@
                         <a:buNone/>
                       </a:pPr>
                       <a:r>
-                        <a:rPr lang="en-US" sz="1080" dirty="0">
+                        <a:rPr lang="en-US" sz="1800" dirty="0">
                           <a:solidFill>
                             <a:srgbClr val="CBD5E1"/>
                           </a:solidFill>
@@ -7356,14 +7358,14 @@
                         </a:rPr>
                         <a:t>QA</a:t>
                       </a:r>
-                      <a:endParaRPr lang="en-US" sz="1080" dirty="0">
+                      <a:endParaRPr lang="en-US" sz="1800" dirty="0">
                         <a:latin typeface="Segoe UI" charset="0"/>
                         <a:ea typeface="Segoe UI" charset="0"/>
                         <a:cs typeface="Segoe UI" charset="0"/>
                       </a:endParaRPr>
                     </a:p>
                   </a:txBody>
-                  <a:tcPr marL="64008" marR="64008" marT="64008" marB="64008" anchor="ctr">
+                  <a:tcPr marL="36576" marR="36576" marT="36576" marB="36576" anchor="ctr">
                     <a:lnL w="6350" cap="flat" cmpd="sng" algn="ctr">
                       <a:solidFill>
                         <a:srgbClr val="24365A"/>
@@ -7414,7 +7416,7 @@
                         <a:buNone/>
                       </a:pPr>
                       <a:r>
-                        <a:rPr lang="en-US" sz="1080" dirty="0">
+                        <a:rPr lang="en-US" sz="1800" dirty="0">
                           <a:solidFill>
                             <a:srgbClr val="CBD5E1"/>
                           </a:solidFill>
@@ -7424,14 +7426,14 @@
                         </a:rPr>
                         <a:t>Own the release gate</a:t>
                       </a:r>
-                      <a:endParaRPr lang="en-US" sz="1080" dirty="0">
+                      <a:endParaRPr lang="en-US" sz="1800" dirty="0">
                         <a:latin typeface="Segoe UI" charset="0"/>
                         <a:ea typeface="Segoe UI" charset="0"/>
                         <a:cs typeface="Segoe UI" charset="0"/>
                       </a:endParaRPr>
                     </a:p>
                   </a:txBody>
-                  <a:tcPr marL="64008" marR="64008" marT="64008" marB="64008" anchor="ctr">
+                  <a:tcPr marL="36576" marR="36576" marT="36576" marB="36576" anchor="ctr">
                     <a:lnL w="6350" cap="flat" cmpd="sng" algn="ctr">
                       <a:solidFill>
                         <a:srgbClr val="24365A"/>
@@ -7482,7 +7484,7 @@
                         <a:buNone/>
                       </a:pPr>
                       <a:r>
-                        <a:rPr lang="en-US" sz="1080" dirty="0">
+                        <a:rPr lang="en-US" sz="1800" dirty="0">
                           <a:solidFill>
                             <a:srgbClr val="CBD5E1"/>
                           </a:solidFill>
@@ -7492,14 +7494,14 @@
                         </a:rPr>
                         <a:t>A blocker stops the line, no exceptions</a:t>
                       </a:r>
-                      <a:endParaRPr lang="en-US" sz="1080" dirty="0">
+                      <a:endParaRPr lang="en-US" sz="1800" dirty="0">
                         <a:latin typeface="Segoe UI" charset="0"/>
                         <a:ea typeface="Segoe UI" charset="0"/>
                         <a:cs typeface="Segoe UI" charset="0"/>
                       </a:endParaRPr>
                     </a:p>
                   </a:txBody>
-                  <a:tcPr marL="64008" marR="64008" marT="64008" marB="64008" anchor="ctr">
+                  <a:tcPr marL="36576" marR="36576" marT="36576" marB="36576" anchor="ctr">
                     <a:lnL w="6350" cap="flat" cmpd="sng" algn="ctr">
                       <a:solidFill>
                         <a:srgbClr val="24365A"/>
@@ -7542,7 +7544,7 @@
                   </a:tcPr>
                 </a:tc>
               </a:tr>
-              <a:tr h="402336">
+              <a:tr h="457200">
                 <a:tc>
                   <a:txBody>
                     <a:bodyPr/>
@@ -7552,7 +7554,7 @@
                         <a:buNone/>
                       </a:pPr>
                       <a:r>
-                        <a:rPr lang="en-US" sz="1080" dirty="0">
+                        <a:rPr lang="en-US" sz="1800" dirty="0">
                           <a:solidFill>
                             <a:srgbClr val="CBD5E1"/>
                           </a:solidFill>
@@ -7562,14 +7564,14 @@
                         </a:rPr>
                         <a:t>PM</a:t>
                       </a:r>
-                      <a:endParaRPr lang="en-US" sz="1080" dirty="0">
+                      <a:endParaRPr lang="en-US" sz="1800" dirty="0">
                         <a:latin typeface="Segoe UI" charset="0"/>
                         <a:ea typeface="Segoe UI" charset="0"/>
                         <a:cs typeface="Segoe UI" charset="0"/>
                       </a:endParaRPr>
                     </a:p>
                   </a:txBody>
-                  <a:tcPr marL="64008" marR="64008" marT="64008" marB="64008" anchor="ctr">
+                  <a:tcPr marL="36576" marR="36576" marT="36576" marB="36576" anchor="ctr">
                     <a:lnL w="6350" cap="flat" cmpd="sng" algn="ctr">
                       <a:solidFill>
                         <a:srgbClr val="24365A"/>
@@ -7620,7 +7622,7 @@
                         <a:buNone/>
                       </a:pPr>
                       <a:r>
-                        <a:rPr lang="en-US" sz="1080" dirty="0">
+                        <a:rPr lang="en-US" sz="1800" dirty="0">
                           <a:solidFill>
                             <a:srgbClr val="CBD5E1"/>
                           </a:solidFill>
@@ -7630,14 +7632,14 @@
                         </a:rPr>
                         <a:t>Track status, priorities, pending decisions</a:t>
                       </a:r>
-                      <a:endParaRPr lang="en-US" sz="1080" dirty="0">
+                      <a:endParaRPr lang="en-US" sz="1800" dirty="0">
                         <a:latin typeface="Segoe UI" charset="0"/>
                         <a:ea typeface="Segoe UI" charset="0"/>
                         <a:cs typeface="Segoe UI" charset="0"/>
                       </a:endParaRPr>
                     </a:p>
                   </a:txBody>
-                  <a:tcPr marL="64008" marR="64008" marT="64008" marB="64008" anchor="ctr">
+                  <a:tcPr marL="36576" marR="36576" marT="36576" marB="36576" anchor="ctr">
                     <a:lnL w="6350" cap="flat" cmpd="sng" algn="ctr">
                       <a:solidFill>
                         <a:srgbClr val="24365A"/>
@@ -7688,7 +7690,7 @@
                         <a:buNone/>
                       </a:pPr>
                       <a:r>
-                        <a:rPr lang="en-US" sz="1080" dirty="0">
+                        <a:rPr lang="en-US" sz="1800" dirty="0">
                           <a:solidFill>
                             <a:srgbClr val="CBD5E1"/>
                           </a:solidFill>
@@ -7698,14 +7700,14 @@
                         </a:rPr>
                         <a:t>Status is truth, not a claim</a:t>
                       </a:r>
-                      <a:endParaRPr lang="en-US" sz="1080" dirty="0">
+                      <a:endParaRPr lang="en-US" sz="1800" dirty="0">
                         <a:latin typeface="Segoe UI" charset="0"/>
                         <a:ea typeface="Segoe UI" charset="0"/>
                         <a:cs typeface="Segoe UI" charset="0"/>
                       </a:endParaRPr>
                     </a:p>
                   </a:txBody>
-                  <a:tcPr marL="64008" marR="64008" marT="64008" marB="64008" anchor="ctr">
+                  <a:tcPr marL="36576" marR="36576" marT="36576" marB="36576" anchor="ctr">
                     <a:lnL w="6350" cap="flat" cmpd="sng" algn="ctr">
                       <a:solidFill>
                         <a:srgbClr val="24365A"/>
@@ -7748,7 +7750,7 @@
                   </a:tcPr>
                 </a:tc>
               </a:tr>
-              <a:tr h="402336">
+              <a:tr h="457200">
                 <a:tc>
                   <a:txBody>
                     <a:bodyPr/>
@@ -7758,7 +7760,7 @@
                         <a:buNone/>
                       </a:pPr>
                       <a:r>
-                        <a:rPr lang="en-US" sz="1080" dirty="0">
+                        <a:rPr lang="en-US" sz="1800" dirty="0">
                           <a:solidFill>
                             <a:srgbClr val="CBD5E1"/>
                           </a:solidFill>
@@ -7768,14 +7770,14 @@
                         </a:rPr>
                         <a:t>Docs</a:t>
                       </a:r>
-                      <a:endParaRPr lang="en-US" sz="1080" dirty="0">
+                      <a:endParaRPr lang="en-US" sz="1800" dirty="0">
                         <a:latin typeface="Segoe UI" charset="0"/>
                         <a:ea typeface="Segoe UI" charset="0"/>
                         <a:cs typeface="Segoe UI" charset="0"/>
                       </a:endParaRPr>
                     </a:p>
                   </a:txBody>
-                  <a:tcPr marL="64008" marR="64008" marT="64008" marB="64008" anchor="ctr">
+                  <a:tcPr marL="36576" marR="36576" marT="36576" marB="36576" anchor="ctr">
                     <a:lnL w="6350" cap="flat" cmpd="sng" algn="ctr">
                       <a:solidFill>
                         <a:srgbClr val="24365A"/>
@@ -7826,7 +7828,7 @@
                         <a:buNone/>
                       </a:pPr>
                       <a:r>
-                        <a:rPr lang="en-US" sz="1080" dirty="0">
+                        <a:rPr lang="en-US" sz="1800" dirty="0">
                           <a:solidFill>
                             <a:srgbClr val="CBD5E1"/>
                           </a:solidFill>
@@ -7836,14 +7838,14 @@
                         </a:rPr>
                         <a:t>Keep rules, decisions, lessons</a:t>
                       </a:r>
-                      <a:endParaRPr lang="en-US" sz="1080" dirty="0">
+                      <a:endParaRPr lang="en-US" sz="1800" dirty="0">
                         <a:latin typeface="Segoe UI" charset="0"/>
                         <a:ea typeface="Segoe UI" charset="0"/>
                         <a:cs typeface="Segoe UI" charset="0"/>
                       </a:endParaRPr>
                     </a:p>
                   </a:txBody>
-                  <a:tcPr marL="64008" marR="64008" marT="64008" marB="64008" anchor="ctr">
+                  <a:tcPr marL="36576" marR="36576" marT="36576" marB="36576" anchor="ctr">
                     <a:lnL w="6350" cap="flat" cmpd="sng" algn="ctr">
                       <a:solidFill>
                         <a:srgbClr val="24365A"/>
@@ -7894,7 +7896,7 @@
                         <a:buNone/>
                       </a:pPr>
                       <a:r>
-                        <a:rPr lang="en-US" sz="1080" dirty="0">
+                        <a:rPr lang="en-US" sz="1800" dirty="0">
                           <a:solidFill>
                             <a:srgbClr val="CBD5E1"/>
                           </a:solidFill>
@@ -7904,14 +7906,14 @@
                         </a:rPr>
                         <a:t>Append-only; old versions archived</a:t>
                       </a:r>
-                      <a:endParaRPr lang="en-US" sz="1080" dirty="0">
+                      <a:endParaRPr lang="en-US" sz="1800" dirty="0">
                         <a:latin typeface="Segoe UI" charset="0"/>
                         <a:ea typeface="Segoe UI" charset="0"/>
                         <a:cs typeface="Segoe UI" charset="0"/>
                       </a:endParaRPr>
                     </a:p>
                   </a:txBody>
-                  <a:tcPr marL="64008" marR="64008" marT="64008" marB="64008" anchor="ctr">
+                  <a:tcPr marL="36576" marR="36576" marT="36576" marB="36576" anchor="ctr">
                     <a:lnL w="6350" cap="flat" cmpd="sng" algn="ctr">
                       <a:solidFill>
                         <a:srgbClr val="24365A"/>
@@ -7954,7 +7956,7 @@
                   </a:tcPr>
                 </a:tc>
               </a:tr>
-              <a:tr h="402336">
+              <a:tr h="457200">
                 <a:tc>
                   <a:txBody>
                     <a:bodyPr/>
@@ -7964,7 +7966,7 @@
                         <a:buNone/>
                       </a:pPr>
                       <a:r>
-                        <a:rPr lang="en-US" sz="1080" dirty="0">
+                        <a:rPr lang="en-US" sz="1800" dirty="0">
                           <a:solidFill>
                             <a:srgbClr val="CBD5E1"/>
                           </a:solidFill>
@@ -7974,14 +7976,14 @@
                         </a:rPr>
                         <a:t>Secretary</a:t>
                       </a:r>
-                      <a:endParaRPr lang="en-US" sz="1080" dirty="0">
+                      <a:endParaRPr lang="en-US" sz="1800" dirty="0">
                         <a:latin typeface="Segoe UI" charset="0"/>
                         <a:ea typeface="Segoe UI" charset="0"/>
                         <a:cs typeface="Segoe UI" charset="0"/>
                       </a:endParaRPr>
                     </a:p>
                   </a:txBody>
-                  <a:tcPr marL="64008" marR="64008" marT="64008" marB="64008" anchor="ctr">
+                  <a:tcPr marL="36576" marR="36576" marT="36576" marB="36576" anchor="ctr">
                     <a:lnL w="6350" cap="flat" cmpd="sng" algn="ctr">
                       <a:solidFill>
                         <a:srgbClr val="24365A"/>
@@ -8032,7 +8034,7 @@
                         <a:buNone/>
                       </a:pPr>
                       <a:r>
-                        <a:rPr lang="en-US" sz="1080" dirty="0">
+                        <a:rPr lang="en-US" sz="1800" dirty="0">
                           <a:solidFill>
                             <a:srgbClr val="CBD5E1"/>
                           </a:solidFill>
@@ -8042,14 +8044,14 @@
                         </a:rPr>
                         <a:t>Portfolio, presentations, content</a:t>
                       </a:r>
-                      <a:endParaRPr lang="en-US" sz="1080" dirty="0">
+                      <a:endParaRPr lang="en-US" sz="1800" dirty="0">
                         <a:latin typeface="Segoe UI" charset="0"/>
                         <a:ea typeface="Segoe UI" charset="0"/>
                         <a:cs typeface="Segoe UI" charset="0"/>
                       </a:endParaRPr>
                     </a:p>
                   </a:txBody>
-                  <a:tcPr marL="64008" marR="64008" marT="64008" marB="64008" anchor="ctr">
+                  <a:tcPr marL="36576" marR="36576" marT="36576" marB="36576" anchor="ctr">
                     <a:lnL w="6350" cap="flat" cmpd="sng" algn="ctr">
                       <a:solidFill>
                         <a:srgbClr val="24365A"/>
@@ -8100,7 +8102,7 @@
                         <a:buNone/>
                       </a:pPr>
                       <a:r>
-                        <a:rPr lang="en-US" sz="1080" dirty="0">
+                        <a:rPr lang="en-US" sz="1800" dirty="0">
                           <a:solidFill>
                             <a:srgbClr val="CBD5E1"/>
                           </a:solidFill>
@@ -8110,14 +8112,14 @@
                         </a:rPr>
                         <a:t>Public output meets the same gates</a:t>
                       </a:r>
-                      <a:endParaRPr lang="en-US" sz="1080" dirty="0">
+                      <a:endParaRPr lang="en-US" sz="1800" dirty="0">
                         <a:latin typeface="Segoe UI" charset="0"/>
                         <a:ea typeface="Segoe UI" charset="0"/>
                         <a:cs typeface="Segoe UI" charset="0"/>
                       </a:endParaRPr>
                     </a:p>
                   </a:txBody>
-                  <a:tcPr marL="64008" marR="64008" marT="64008" marB="64008" anchor="ctr">
+                  <a:tcPr marL="36576" marR="36576" marT="36576" marB="36576" anchor="ctr">
                     <a:lnL w="6350" cap="flat" cmpd="sng" algn="ctr">
                       <a:solidFill>
                         <a:srgbClr val="24365A"/>
@@ -8160,7 +8162,7 @@
                   </a:tcPr>
                 </a:tc>
               </a:tr>
-              <a:tr h="402336">
+              <a:tr h="457200">
                 <a:tc>
                   <a:txBody>
                     <a:bodyPr/>
@@ -8170,7 +8172,7 @@
                         <a:buNone/>
                       </a:pPr>
                       <a:r>
-                        <a:rPr lang="en-US" sz="1080" dirty="0">
+                        <a:rPr lang="en-US" sz="1800" dirty="0">
                           <a:solidFill>
                             <a:srgbClr val="CBD5E1"/>
                           </a:solidFill>
@@ -8180,14 +8182,14 @@
                         </a:rPr>
                         <a:t>Specialists</a:t>
                       </a:r>
-                      <a:endParaRPr lang="en-US" sz="1080" dirty="0">
+                      <a:endParaRPr lang="en-US" sz="1800" dirty="0">
                         <a:latin typeface="Segoe UI" charset="0"/>
                         <a:ea typeface="Segoe UI" charset="0"/>
                         <a:cs typeface="Segoe UI" charset="0"/>
                       </a:endParaRPr>
                     </a:p>
                   </a:txBody>
-                  <a:tcPr marL="64008" marR="64008" marT="64008" marB="64008" anchor="ctr">
+                  <a:tcPr marL="36576" marR="36576" marT="36576" marB="36576" anchor="ctr">
                     <a:lnL w="6350" cap="flat" cmpd="sng" algn="ctr">
                       <a:solidFill>
                         <a:srgbClr val="24365A"/>
@@ -8238,7 +8240,7 @@
                         <a:buNone/>
                       </a:pPr>
                       <a:r>
-                        <a:rPr lang="en-US" sz="1080" dirty="0">
+                        <a:rPr lang="en-US" sz="1800" dirty="0">
                           <a:solidFill>
                             <a:srgbClr val="CBD5E1"/>
                           </a:solidFill>
@@ -8248,14 +8250,14 @@
                         </a:rPr>
                         <a:t>Data, GIS, OSINT, watchdog</a:t>
                       </a:r>
-                      <a:endParaRPr lang="en-US" sz="1080" dirty="0">
+                      <a:endParaRPr lang="en-US" sz="1800" dirty="0">
                         <a:latin typeface="Segoe UI" charset="0"/>
                         <a:ea typeface="Segoe UI" charset="0"/>
                         <a:cs typeface="Segoe UI" charset="0"/>
                       </a:endParaRPr>
                     </a:p>
                   </a:txBody>
-                  <a:tcPr marL="64008" marR="64008" marT="64008" marB="64008" anchor="ctr">
+                  <a:tcPr marL="36576" marR="36576" marT="36576" marB="36576" anchor="ctr">
                     <a:lnL w="6350" cap="flat" cmpd="sng" algn="ctr">
                       <a:solidFill>
                         <a:srgbClr val="24365A"/>
@@ -8306,7 +8308,7 @@
                         <a:buNone/>
                       </a:pPr>
                       <a:r>
-                        <a:rPr lang="en-US" sz="1080" dirty="0">
+                        <a:rPr lang="en-US" sz="1800" dirty="0">
                           <a:solidFill>
                             <a:srgbClr val="CBD5E1"/>
                           </a:solidFill>
@@ -8316,14 +8318,14 @@
                         </a:rPr>
                         <a:t>Public data only; provenance attached</a:t>
                       </a:r>
-                      <a:endParaRPr lang="en-US" sz="1080" dirty="0">
+                      <a:endParaRPr lang="en-US" sz="1800" dirty="0">
                         <a:latin typeface="Segoe UI" charset="0"/>
                         <a:ea typeface="Segoe UI" charset="0"/>
                         <a:cs typeface="Segoe UI" charset="0"/>
                       </a:endParaRPr>
                     </a:p>
                   </a:txBody>
-                  <a:tcPr marL="64008" marR="64008" marT="64008" marB="64008" anchor="ctr">
+                  <a:tcPr marL="36576" marR="36576" marT="36576" marB="36576" anchor="ctr">
                     <a:lnL w="6350" cap="flat" cmpd="sng" algn="ctr">
                       <a:solidFill>
                         <a:srgbClr val="24365A"/>
@@ -8401,8 +8403,8 @@
         </p:nvSpPr>
         <p:spPr>
           <a:xfrm>
-            <a:off x="822960" y="6053328"/>
-            <a:ext cx="9692640" cy="457200"/>
+            <a:off x="822960" y="6035040"/>
+            <a:ext cx="10424160" cy="566928"/>
           </a:xfrm>
           <a:prstGeom prst="rect">
             <a:avLst/>
@@ -8418,9 +8420,9 @@
               <a:buNone/>
             </a:pPr>
             <a:r>
-              <a:rPr lang="en-US" sz="1150" dirty="0">
-                <a:solidFill>
-                  <a:srgbClr val="64748B"/>
+              <a:rPr lang="en-US" sz="1800" dirty="0">
+                <a:solidFill>
+                  <a:srgbClr val="8FA3BF"/>
                 </a:solidFill>
                 <a:latin typeface="Segoe UI" pitchFamily="34" charset="0"/>
                 <a:ea typeface="Segoe UI" pitchFamily="34" charset="-122"/>
@@ -8428,7 +8430,7 @@
               </a:rPr>
               <a:t>Six rows, nine agents - the specialists share one row and the same discipline.</a:t>
             </a:r>
-            <a:endParaRPr lang="en-US" sz="1150" dirty="0"/>
+            <a:endParaRPr lang="en-US" sz="1800" dirty="0"/>
           </a:p>
         </p:txBody>
       </p:sp>
@@ -8440,8 +8442,8 @@
         </p:nvSpPr>
         <p:spPr>
           <a:xfrm>
-            <a:off x="10698480" y="6382512"/>
-            <a:ext cx="1188720" cy="365760"/>
+            <a:off x="10698480" y="6309360"/>
+            <a:ext cx="1188720" cy="411480"/>
           </a:xfrm>
           <a:prstGeom prst="rect">
             <a:avLst/>
@@ -8457,9 +8459,9 @@
               <a:buNone/>
             </a:pPr>
             <a:r>
-              <a:rPr lang="en-US" sz="1000" dirty="0">
-                <a:solidFill>
-                  <a:srgbClr val="64748B"/>
+              <a:rPr lang="en-US" sz="1800" dirty="0">
+                <a:solidFill>
+                  <a:srgbClr val="8FA3BF"/>
                 </a:solidFill>
                 <a:latin typeface="Consolas" pitchFamily="34" charset="0"/>
                 <a:ea typeface="Consolas" pitchFamily="34" charset="-122"/>
@@ -8467,7 +8469,7 @@
               </a:rPr>
               <a:t>4 / 14</a:t>
             </a:r>
-            <a:endParaRPr lang="en-US" sz="1000" dirty="0"/>
+            <a:endParaRPr lang="en-US" sz="1800" dirty="0"/>
           </a:p>
         </p:txBody>
       </p:sp>
@@ -8551,8 +8553,8 @@
         </p:nvSpPr>
         <p:spPr>
           <a:xfrm>
-            <a:off x="822960" y="502920"/>
-            <a:ext cx="10515600" cy="365760"/>
+            <a:off x="822960" y="457200"/>
+            <a:ext cx="10515600" cy="411480"/>
           </a:xfrm>
           <a:prstGeom prst="rect">
             <a:avLst/>
@@ -8568,7 +8570,7 @@
               <a:buNone/>
             </a:pPr>
             <a:r>
-              <a:rPr lang="en-US" sz="1200" spc="300" kern="0" dirty="0">
+              <a:rPr lang="en-US" sz="1800" spc="300" kern="0" dirty="0">
                 <a:solidFill>
                   <a:srgbClr val="06B6D4"/>
                 </a:solidFill>
@@ -8578,7 +8580,7 @@
               </a:rPr>
               <a:t>REQUEST LIFECYCLE</a:t>
             </a:r>
-            <a:endParaRPr lang="en-US" sz="1200" dirty="0"/>
+            <a:endParaRPr lang="en-US" sz="1800" dirty="0"/>
           </a:p>
         </p:txBody>
       </p:sp>
@@ -8629,8 +8631,8 @@
         </p:nvSpPr>
         <p:spPr>
           <a:xfrm>
-            <a:off x="774040" y="2514600"/>
-            <a:ext cx="1938528" cy="2103120"/>
+            <a:off x="774040" y="2331720"/>
+            <a:ext cx="1938528" cy="2697480"/>
           </a:xfrm>
           <a:prstGeom prst="roundRect">
             <a:avLst>
@@ -8656,8 +8658,8 @@
         </p:nvSpPr>
         <p:spPr>
           <a:xfrm>
-            <a:off x="902056" y="2633472"/>
-            <a:ext cx="1682496" cy="310896"/>
+            <a:off x="902056" y="2450592"/>
+            <a:ext cx="1682496" cy="365760"/>
           </a:xfrm>
           <a:prstGeom prst="rect">
             <a:avLst/>
@@ -8673,7 +8675,7 @@
               <a:buNone/>
             </a:pPr>
             <a:r>
-              <a:rPr lang="en-US" sz="1100" b="1" dirty="0">
+              <a:rPr lang="en-US" sz="1800" b="1" dirty="0">
                 <a:solidFill>
                   <a:srgbClr val="3B82F6"/>
                 </a:solidFill>
@@ -8683,7 +8685,7 @@
               </a:rPr>
               <a:t>01</a:t>
             </a:r>
-            <a:endParaRPr lang="en-US" sz="1100" dirty="0"/>
+            <a:endParaRPr lang="en-US" sz="1800" dirty="0"/>
           </a:p>
         </p:txBody>
       </p:sp>
@@ -8695,8 +8697,8 @@
         </p:nvSpPr>
         <p:spPr>
           <a:xfrm>
-            <a:off x="902056" y="2962656"/>
-            <a:ext cx="1682496" cy="566928"/>
+            <a:off x="902056" y="2834640"/>
+            <a:ext cx="1682496" cy="713232"/>
           </a:xfrm>
           <a:prstGeom prst="rect">
             <a:avLst/>
@@ -8712,7 +8714,7 @@
               <a:buNone/>
             </a:pPr>
             <a:r>
-              <a:rPr lang="en-US" sz="1350" b="1" dirty="0">
+              <a:rPr lang="en-US" sz="1800" b="1" dirty="0">
                 <a:solidFill>
                   <a:srgbClr val="FFFFFF"/>
                 </a:solidFill>
@@ -8722,7 +8724,7 @@
               </a:rPr>
               <a:t>Brief</a:t>
             </a:r>
-            <a:endParaRPr lang="en-US" sz="1350" dirty="0"/>
+            <a:endParaRPr lang="en-US" sz="1800" dirty="0"/>
           </a:p>
         </p:txBody>
       </p:sp>
@@ -8734,8 +8736,8 @@
         </p:nvSpPr>
         <p:spPr>
           <a:xfrm>
-            <a:off x="902056" y="3566160"/>
-            <a:ext cx="1682496" cy="960120"/>
+            <a:off x="902056" y="3584448"/>
+            <a:ext cx="1682496" cy="1371600"/>
           </a:xfrm>
           <a:prstGeom prst="rect">
             <a:avLst/>
@@ -8751,7 +8753,7 @@
               <a:buNone/>
             </a:pPr>
             <a:r>
-              <a:rPr lang="en-US" sz="980" dirty="0">
+              <a:rPr lang="en-US" sz="1800" dirty="0">
                 <a:solidFill>
                   <a:srgbClr val="CBD5E1"/>
                 </a:solidFill>
@@ -8761,7 +8763,7 @@
               </a:rPr>
               <a:t>A task enters with acceptance criteria and a named owner agent.</a:t>
             </a:r>
-            <a:endParaRPr lang="en-US" sz="980" dirty="0"/>
+            <a:endParaRPr lang="en-US" sz="1800" dirty="0"/>
           </a:p>
         </p:txBody>
       </p:sp>
@@ -8773,7 +8775,7 @@
         </p:nvSpPr>
         <p:spPr>
           <a:xfrm>
-            <a:off x="2726284" y="3419856"/>
+            <a:off x="2726284" y="3566160"/>
             <a:ext cx="210312" cy="274320"/>
           </a:xfrm>
           <a:prstGeom prst="rightArrow">
@@ -8793,8 +8795,8 @@
         </p:nvSpPr>
         <p:spPr>
           <a:xfrm>
-            <a:off x="2950312" y="2514600"/>
-            <a:ext cx="1938528" cy="2103120"/>
+            <a:off x="2950312" y="2331720"/>
+            <a:ext cx="1938528" cy="2697480"/>
           </a:xfrm>
           <a:prstGeom prst="roundRect">
             <a:avLst>
@@ -8820,8 +8822,8 @@
         </p:nvSpPr>
         <p:spPr>
           <a:xfrm>
-            <a:off x="3078328" y="2633472"/>
-            <a:ext cx="1682496" cy="310896"/>
+            <a:off x="3078328" y="2450592"/>
+            <a:ext cx="1682496" cy="365760"/>
           </a:xfrm>
           <a:prstGeom prst="rect">
             <a:avLst/>
@@ -8837,7 +8839,7 @@
               <a:buNone/>
             </a:pPr>
             <a:r>
-              <a:rPr lang="en-US" sz="1100" b="1" dirty="0">
+              <a:rPr lang="en-US" sz="1800" b="1" dirty="0">
                 <a:solidFill>
                   <a:srgbClr val="06B6D4"/>
                 </a:solidFill>
@@ -8847,7 +8849,7 @@
               </a:rPr>
               <a:t>02</a:t>
             </a:r>
-            <a:endParaRPr lang="en-US" sz="1100" dirty="0"/>
+            <a:endParaRPr lang="en-US" sz="1800" dirty="0"/>
           </a:p>
         </p:txBody>
       </p:sp>
@@ -8859,8 +8861,8 @@
         </p:nvSpPr>
         <p:spPr>
           <a:xfrm>
-            <a:off x="3078328" y="2962656"/>
-            <a:ext cx="1682496" cy="566928"/>
+            <a:off x="3078328" y="2834640"/>
+            <a:ext cx="1682496" cy="713232"/>
           </a:xfrm>
           <a:prstGeom prst="rect">
             <a:avLst/>
@@ -8876,7 +8878,7 @@
               <a:buNone/>
             </a:pPr>
             <a:r>
-              <a:rPr lang="en-US" sz="1350" b="1" dirty="0">
+              <a:rPr lang="en-US" sz="1800" b="1" dirty="0">
                 <a:solidFill>
                   <a:srgbClr val="FFFFFF"/>
                 </a:solidFill>
@@ -8886,7 +8888,7 @@
               </a:rPr>
               <a:t>Queue</a:t>
             </a:r>
-            <a:endParaRPr lang="en-US" sz="1350" dirty="0"/>
+            <a:endParaRPr lang="en-US" sz="1800" dirty="0"/>
           </a:p>
         </p:txBody>
       </p:sp>
@@ -8898,8 +8900,8 @@
         </p:nvSpPr>
         <p:spPr>
           <a:xfrm>
-            <a:off x="3078328" y="3566160"/>
-            <a:ext cx="1682496" cy="960120"/>
+            <a:off x="3078328" y="3584448"/>
+            <a:ext cx="1682496" cy="1371600"/>
           </a:xfrm>
           <a:prstGeom prst="rect">
             <a:avLst/>
@@ -8915,7 +8917,7 @@
               <a:buNone/>
             </a:pPr>
             <a:r>
-              <a:rPr lang="en-US" sz="980" dirty="0">
+              <a:rPr lang="en-US" sz="1800" dirty="0">
                 <a:solidFill>
                   <a:srgbClr val="CBD5E1"/>
                 </a:solidFill>
@@ -8925,7 +8927,7 @@
               </a:rPr>
               <a:t>It lands in that agent's own queue, so parallel work never collides.</a:t>
             </a:r>
-            <a:endParaRPr lang="en-US" sz="980" dirty="0"/>
+            <a:endParaRPr lang="en-US" sz="1800" dirty="0"/>
           </a:p>
         </p:txBody>
       </p:sp>
@@ -8937,7 +8939,7 @@
         </p:nvSpPr>
         <p:spPr>
           <a:xfrm>
-            <a:off x="4902556" y="3419856"/>
+            <a:off x="4902556" y="3566160"/>
             <a:ext cx="210312" cy="274320"/>
           </a:xfrm>
           <a:prstGeom prst="rightArrow">
@@ -8957,8 +8959,8 @@
         </p:nvSpPr>
         <p:spPr>
           <a:xfrm>
-            <a:off x="5126584" y="2514600"/>
-            <a:ext cx="1938528" cy="2103120"/>
+            <a:off x="5126584" y="2331720"/>
+            <a:ext cx="1938528" cy="2697480"/>
           </a:xfrm>
           <a:prstGeom prst="roundRect">
             <a:avLst>
@@ -8984,8 +8986,8 @@
         </p:nvSpPr>
         <p:spPr>
           <a:xfrm>
-            <a:off x="5254600" y="2633472"/>
-            <a:ext cx="1682496" cy="310896"/>
+            <a:off x="5254600" y="2450592"/>
+            <a:ext cx="1682496" cy="365760"/>
           </a:xfrm>
           <a:prstGeom prst="rect">
             <a:avLst/>
@@ -9001,7 +9003,7 @@
               <a:buNone/>
             </a:pPr>
             <a:r>
-              <a:rPr lang="en-US" sz="1100" b="1" dirty="0">
+              <a:rPr lang="en-US" sz="1800" b="1" dirty="0">
                 <a:solidFill>
                   <a:srgbClr val="3B82F6"/>
                 </a:solidFill>
@@ -9011,7 +9013,7 @@
               </a:rPr>
               <a:t>03</a:t>
             </a:r>
-            <a:endParaRPr lang="en-US" sz="1100" dirty="0"/>
+            <a:endParaRPr lang="en-US" sz="1800" dirty="0"/>
           </a:p>
         </p:txBody>
       </p:sp>
@@ -9023,8 +9025,8 @@
         </p:nvSpPr>
         <p:spPr>
           <a:xfrm>
-            <a:off x="5254600" y="2962656"/>
-            <a:ext cx="1682496" cy="566928"/>
+            <a:off x="5254600" y="2834640"/>
+            <a:ext cx="1682496" cy="713232"/>
           </a:xfrm>
           <a:prstGeom prst="rect">
             <a:avLst/>
@@ -9040,7 +9042,7 @@
               <a:buNone/>
             </a:pPr>
             <a:r>
-              <a:rPr lang="en-US" sz="1350" b="1" dirty="0">
+              <a:rPr lang="en-US" sz="1800" b="1" dirty="0">
                 <a:solidFill>
                   <a:srgbClr val="FFFFFF"/>
                 </a:solidFill>
@@ -9050,7 +9052,7 @@
               </a:rPr>
               <a:t>Execute</a:t>
             </a:r>
-            <a:endParaRPr lang="en-US" sz="1350" dirty="0"/>
+            <a:endParaRPr lang="en-US" sz="1800" dirty="0"/>
           </a:p>
         </p:txBody>
       </p:sp>
@@ -9062,8 +9064,8 @@
         </p:nvSpPr>
         <p:spPr>
           <a:xfrm>
-            <a:off x="5254600" y="3566160"/>
-            <a:ext cx="1682496" cy="960120"/>
+            <a:off x="5254600" y="3584448"/>
+            <a:ext cx="1682496" cy="1371600"/>
           </a:xfrm>
           <a:prstGeom prst="rect">
             <a:avLst/>
@@ -9079,7 +9081,7 @@
               <a:buNone/>
             </a:pPr>
             <a:r>
-              <a:rPr lang="en-US" sz="980" dirty="0">
+              <a:rPr lang="en-US" sz="1800" dirty="0">
                 <a:solidFill>
                   <a:srgbClr val="CBD5E1"/>
                 </a:solidFill>
@@ -9089,7 +9091,7 @@
               </a:rPr>
               <a:t>The agent reads shared memory, does the scoped work, and records evidence.</a:t>
             </a:r>
-            <a:endParaRPr lang="en-US" sz="980" dirty="0"/>
+            <a:endParaRPr lang="en-US" sz="1800" dirty="0"/>
           </a:p>
         </p:txBody>
       </p:sp>
@@ -9101,7 +9103,7 @@
         </p:nvSpPr>
         <p:spPr>
           <a:xfrm>
-            <a:off x="7078828" y="3419856"/>
+            <a:off x="7078828" y="3566160"/>
             <a:ext cx="210312" cy="274320"/>
           </a:xfrm>
           <a:prstGeom prst="rightArrow">
@@ -9121,8 +9123,8 @@
         </p:nvSpPr>
         <p:spPr>
           <a:xfrm>
-            <a:off x="7302856" y="2514600"/>
-            <a:ext cx="1938528" cy="2103120"/>
+            <a:off x="7302856" y="2331720"/>
+            <a:ext cx="1938528" cy="2697480"/>
           </a:xfrm>
           <a:prstGeom prst="roundRect">
             <a:avLst>
@@ -9148,8 +9150,8 @@
         </p:nvSpPr>
         <p:spPr>
           <a:xfrm>
-            <a:off x="7430872" y="2633472"/>
-            <a:ext cx="1682496" cy="310896"/>
+            <a:off x="7430872" y="2450592"/>
+            <a:ext cx="1682496" cy="365760"/>
           </a:xfrm>
           <a:prstGeom prst="rect">
             <a:avLst/>
@@ -9165,7 +9167,7 @@
               <a:buNone/>
             </a:pPr>
             <a:r>
-              <a:rPr lang="en-US" sz="1100" b="1" dirty="0">
+              <a:rPr lang="en-US" sz="1800" b="1" dirty="0">
                 <a:solidFill>
                   <a:srgbClr val="06B6D4"/>
                 </a:solidFill>
@@ -9175,7 +9177,7 @@
               </a:rPr>
               <a:t>04</a:t>
             </a:r>
-            <a:endParaRPr lang="en-US" sz="1100" dirty="0"/>
+            <a:endParaRPr lang="en-US" sz="1800" dirty="0"/>
           </a:p>
         </p:txBody>
       </p:sp>
@@ -9187,8 +9189,8 @@
         </p:nvSpPr>
         <p:spPr>
           <a:xfrm>
-            <a:off x="7430872" y="2962656"/>
-            <a:ext cx="1682496" cy="566928"/>
+            <a:off x="7430872" y="2834640"/>
+            <a:ext cx="1682496" cy="713232"/>
           </a:xfrm>
           <a:prstGeom prst="rect">
             <a:avLst/>
@@ -9204,7 +9206,7 @@
               <a:buNone/>
             </a:pPr>
             <a:r>
-              <a:rPr lang="en-US" sz="1350" b="1" dirty="0">
+              <a:rPr lang="en-US" sz="1800" b="1" dirty="0">
                 <a:solidFill>
                   <a:srgbClr val="FFFFFF"/>
                 </a:solidFill>
@@ -9214,7 +9216,7 @@
               </a:rPr>
               <a:t>Verify</a:t>
             </a:r>
-            <a:endParaRPr lang="en-US" sz="1350" dirty="0"/>
+            <a:endParaRPr lang="en-US" sz="1800" dirty="0"/>
           </a:p>
         </p:txBody>
       </p:sp>
@@ -9226,8 +9228,8 @@
         </p:nvSpPr>
         <p:spPr>
           <a:xfrm>
-            <a:off x="7430872" y="3566160"/>
-            <a:ext cx="1682496" cy="960120"/>
+            <a:off x="7430872" y="3584448"/>
+            <a:ext cx="1682496" cy="1371600"/>
           </a:xfrm>
           <a:prstGeom prst="rect">
             <a:avLst/>
@@ -9243,7 +9245,7 @@
               <a:buNone/>
             </a:pPr>
             <a:r>
-              <a:rPr lang="en-US" sz="980" dirty="0">
+              <a:rPr lang="en-US" sz="1800" dirty="0">
                 <a:solidFill>
                   <a:srgbClr val="CBD5E1"/>
                 </a:solidFill>
@@ -9253,7 +9255,7 @@
               </a:rPr>
               <a:t>QA and the quality gate check claims against artifacts, not status fields.</a:t>
             </a:r>
-            <a:endParaRPr lang="en-US" sz="980" dirty="0"/>
+            <a:endParaRPr lang="en-US" sz="1800" dirty="0"/>
           </a:p>
         </p:txBody>
       </p:sp>
@@ -9265,7 +9267,7 @@
         </p:nvSpPr>
         <p:spPr>
           <a:xfrm>
-            <a:off x="9255100" y="3419856"/>
+            <a:off x="9255100" y="3566160"/>
             <a:ext cx="210312" cy="274320"/>
           </a:xfrm>
           <a:prstGeom prst="rightArrow">
@@ -9285,8 +9287,8 @@
         </p:nvSpPr>
         <p:spPr>
           <a:xfrm>
-            <a:off x="9479128" y="2514600"/>
-            <a:ext cx="1938528" cy="2103120"/>
+            <a:off x="9479128" y="2331720"/>
+            <a:ext cx="1938528" cy="2697480"/>
           </a:xfrm>
           <a:prstGeom prst="roundRect">
             <a:avLst>
@@ -9312,8 +9314,8 @@
         </p:nvSpPr>
         <p:spPr>
           <a:xfrm>
-            <a:off x="9607144" y="2633472"/>
-            <a:ext cx="1682496" cy="310896"/>
+            <a:off x="9607144" y="2450592"/>
+            <a:ext cx="1682496" cy="365760"/>
           </a:xfrm>
           <a:prstGeom prst="rect">
             <a:avLst/>
@@ -9329,7 +9331,7 @@
               <a:buNone/>
             </a:pPr>
             <a:r>
-              <a:rPr lang="en-US" sz="1100" b="1" dirty="0">
+              <a:rPr lang="en-US" sz="1800" b="1" dirty="0">
                 <a:solidFill>
                   <a:srgbClr val="3B82F6"/>
                 </a:solidFill>
@@ -9339,7 +9341,7 @@
               </a:rPr>
               <a:t>05</a:t>
             </a:r>
-            <a:endParaRPr lang="en-US" sz="1100" dirty="0"/>
+            <a:endParaRPr lang="en-US" sz="1800" dirty="0"/>
           </a:p>
         </p:txBody>
       </p:sp>
@@ -9351,8 +9353,8 @@
         </p:nvSpPr>
         <p:spPr>
           <a:xfrm>
-            <a:off x="9607144" y="2962656"/>
-            <a:ext cx="1682496" cy="566928"/>
+            <a:off x="9607144" y="2834640"/>
+            <a:ext cx="1682496" cy="713232"/>
           </a:xfrm>
           <a:prstGeom prst="rect">
             <a:avLst/>
@@ -9368,7 +9370,7 @@
               <a:buNone/>
             </a:pPr>
             <a:r>
-              <a:rPr lang="en-US" sz="1350" b="1" dirty="0">
+              <a:rPr lang="en-US" sz="1800" b="1" dirty="0">
                 <a:solidFill>
                   <a:srgbClr val="FFFFFF"/>
                 </a:solidFill>
@@ -9378,7 +9380,7 @@
               </a:rPr>
               <a:t>Approve</a:t>
             </a:r>
-            <a:endParaRPr lang="en-US" sz="1350" dirty="0"/>
+            <a:endParaRPr lang="en-US" sz="1800" dirty="0"/>
           </a:p>
         </p:txBody>
       </p:sp>
@@ -9390,8 +9392,8 @@
         </p:nvSpPr>
         <p:spPr>
           <a:xfrm>
-            <a:off x="9607144" y="3566160"/>
-            <a:ext cx="1682496" cy="960120"/>
+            <a:off x="9607144" y="3584448"/>
+            <a:ext cx="1682496" cy="1371600"/>
           </a:xfrm>
           <a:prstGeom prst="rect">
             <a:avLst/>
@@ -9407,7 +9409,7 @@
               <a:buNone/>
             </a:pPr>
             <a:r>
-              <a:rPr lang="en-US" sz="980" dirty="0">
+              <a:rPr lang="en-US" sz="1800" dirty="0">
                 <a:solidFill>
                   <a:srgbClr val="CBD5E1"/>
                 </a:solidFill>
@@ -9417,7 +9419,7 @@
               </a:rPr>
               <a:t>Anything that needs the human goes to the approval queue; verdicts are visible.</a:t>
             </a:r>
-            <a:endParaRPr lang="en-US" sz="980" dirty="0"/>
+            <a:endParaRPr lang="en-US" sz="1800" dirty="0"/>
           </a:p>
         </p:txBody>
       </p:sp>
@@ -9452,8 +9454,8 @@
         </p:nvSpPr>
         <p:spPr>
           <a:xfrm>
-            <a:off x="822960" y="6053328"/>
-            <a:ext cx="9692640" cy="457200"/>
+            <a:off x="822960" y="6035040"/>
+            <a:ext cx="10424160" cy="566928"/>
           </a:xfrm>
           <a:prstGeom prst="rect">
             <a:avLst/>
@@ -9469,9 +9471,9 @@
               <a:buNone/>
             </a:pPr>
             <a:r>
-              <a:rPr lang="en-US" sz="1150" dirty="0">
-                <a:solidFill>
-                  <a:srgbClr val="64748B"/>
+              <a:rPr lang="en-US" sz="1800" dirty="0">
+                <a:solidFill>
+                  <a:srgbClr val="8FA3BF"/>
                 </a:solidFill>
                 <a:latin typeface="Segoe UI" pitchFamily="34" charset="0"/>
                 <a:ea typeface="Segoe UI" pitchFamily="34" charset="-122"/>
@@ -9479,7 +9481,7 @@
               </a:rPr>
               <a:t>Every arrow is a protocol, not a habit.</a:t>
             </a:r>
-            <a:endParaRPr lang="en-US" sz="1150" dirty="0"/>
+            <a:endParaRPr lang="en-US" sz="1800" dirty="0"/>
           </a:p>
         </p:txBody>
       </p:sp>
@@ -9491,8 +9493,8 @@
         </p:nvSpPr>
         <p:spPr>
           <a:xfrm>
-            <a:off x="10698480" y="6382512"/>
-            <a:ext cx="1188720" cy="365760"/>
+            <a:off x="10698480" y="6309360"/>
+            <a:ext cx="1188720" cy="411480"/>
           </a:xfrm>
           <a:prstGeom prst="rect">
             <a:avLst/>
@@ -9508,9 +9510,9 @@
               <a:buNone/>
             </a:pPr>
             <a:r>
-              <a:rPr lang="en-US" sz="1000" dirty="0">
-                <a:solidFill>
-                  <a:srgbClr val="64748B"/>
+              <a:rPr lang="en-US" sz="1800" dirty="0">
+                <a:solidFill>
+                  <a:srgbClr val="8FA3BF"/>
                 </a:solidFill>
                 <a:latin typeface="Consolas" pitchFamily="34" charset="0"/>
                 <a:ea typeface="Consolas" pitchFamily="34" charset="-122"/>
@@ -9518,7 +9520,7 @@
               </a:rPr>
               <a:t>5 / 14</a:t>
             </a:r>
-            <a:endParaRPr lang="en-US" sz="1000" dirty="0"/>
+            <a:endParaRPr lang="en-US" sz="1800" dirty="0"/>
           </a:p>
         </p:txBody>
       </p:sp>
@@ -9602,8 +9604,8 @@
         </p:nvSpPr>
         <p:spPr>
           <a:xfrm>
-            <a:off x="822960" y="502920"/>
-            <a:ext cx="10515600" cy="365760"/>
+            <a:off x="822960" y="457200"/>
+            <a:ext cx="10515600" cy="411480"/>
           </a:xfrm>
           <a:prstGeom prst="rect">
             <a:avLst/>
@@ -9619,7 +9621,7 @@
               <a:buNone/>
             </a:pPr>
             <a:r>
-              <a:rPr lang="en-US" sz="1200" spc="300" kern="0" dirty="0">
+              <a:rPr lang="en-US" sz="1800" spc="300" kern="0" dirty="0">
                 <a:solidFill>
                   <a:srgbClr val="06B6D4"/>
                 </a:solidFill>
@@ -9629,7 +9631,7 @@
               </a:rPr>
               <a:t>PROTOCOL 1 &amp; 2</a:t>
             </a:r>
-            <a:endParaRPr lang="en-US" sz="1200" dirty="0"/>
+            <a:endParaRPr lang="en-US" sz="1800" dirty="0"/>
           </a:p>
         </p:txBody>
       </p:sp>
@@ -9680,8 +9682,8 @@
         </p:nvSpPr>
         <p:spPr>
           <a:xfrm>
-            <a:off x="868680" y="2011680"/>
-            <a:ext cx="10424160" cy="3566160"/>
+            <a:off x="868680" y="1965960"/>
+            <a:ext cx="10424160" cy="3840480"/>
           </a:xfrm>
           <a:prstGeom prst="rect">
             <a:avLst/>
@@ -9704,7 +9706,7 @@
               <a:buChar char="▸"/>
             </a:pPr>
             <a:r>
-              <a:rPr lang="en-US" sz="1600" dirty="0">
+              <a:rPr lang="en-US" sz="2000" dirty="0">
                 <a:solidFill>
                   <a:srgbClr val="CBD5E1"/>
                 </a:solidFill>
@@ -9714,7 +9716,7 @@
               </a:rPr>
               <a:t>One structured knowledge base holds rules, status, and lessons in strict formats every agent reads before working.</a:t>
             </a:r>
-            <a:endParaRPr lang="en-US" sz="1600" dirty="0"/>
+            <a:endParaRPr lang="en-US" sz="2000" dirty="0"/>
           </a:p>
           <a:p>
             <a:pPr marL="342900" indent="-342900">
@@ -9728,7 +9730,7 @@
               <a:buChar char="▸"/>
             </a:pPr>
             <a:r>
-              <a:rPr lang="en-US" sz="1600" dirty="0">
+              <a:rPr lang="en-US" sz="2000" dirty="0">
                 <a:solidFill>
                   <a:srgbClr val="CBD5E1"/>
                 </a:solidFill>
@@ -9738,7 +9740,7 @@
               </a:rPr>
               <a:t>Contradictions become visible instead of buried in chat history, and new agents onboard by reading.</a:t>
             </a:r>
-            <a:endParaRPr lang="en-US" sz="1600" dirty="0"/>
+            <a:endParaRPr lang="en-US" sz="2000" dirty="0"/>
           </a:p>
           <a:p>
             <a:pPr marL="342900" indent="-342900">
@@ -9752,7 +9754,7 @@
               <a:buChar char="▸"/>
             </a:pPr>
             <a:r>
-              <a:rPr lang="en-US" sz="1600" dirty="0">
+              <a:rPr lang="en-US" sz="2000" dirty="0">
                 <a:solidFill>
                   <a:srgbClr val="CBD5E1"/>
                 </a:solidFill>
@@ -9762,7 +9764,7 @@
               </a:rPr>
               <a:t>Every claim needs a log, file, or marker; a status field is not evidence.</a:t>
             </a:r>
-            <a:endParaRPr lang="en-US" sz="1600" dirty="0"/>
+            <a:endParaRPr lang="en-US" sz="2000" dirty="0"/>
           </a:p>
           <a:p>
             <a:pPr marL="342900" indent="-342900">
@@ -9776,7 +9778,7 @@
               <a:buChar char="▸"/>
             </a:pPr>
             <a:r>
-              <a:rPr lang="en-US" sz="1600" dirty="0">
+              <a:rPr lang="en-US" sz="2000" dirty="0">
                 <a:solidFill>
                   <a:srgbClr val="CBD5E1"/>
                 </a:solidFill>
@@ -9786,7 +9788,7 @@
               </a:rPr>
               <a:t>Failure reports are mandatory and never silently requeued, because fake green checkmarks are bugs.</a:t>
             </a:r>
-            <a:endParaRPr lang="en-US" sz="1600" dirty="0"/>
+            <a:endParaRPr lang="en-US" sz="2000" dirty="0"/>
           </a:p>
         </p:txBody>
       </p:sp>
@@ -9821,8 +9823,8 @@
         </p:nvSpPr>
         <p:spPr>
           <a:xfrm>
-            <a:off x="822960" y="6053328"/>
-            <a:ext cx="9692640" cy="457200"/>
+            <a:off x="822960" y="6035040"/>
+            <a:ext cx="10424160" cy="566928"/>
           </a:xfrm>
           <a:prstGeom prst="rect">
             <a:avLst/>
@@ -9838,9 +9840,9 @@
               <a:buNone/>
             </a:pPr>
             <a:r>
-              <a:rPr lang="en-US" sz="1150" dirty="0">
-                <a:solidFill>
-                  <a:srgbClr val="64748B"/>
+              <a:rPr lang="en-US" sz="1800" dirty="0">
+                <a:solidFill>
+                  <a:srgbClr val="8FA3BF"/>
                 </a:solidFill>
                 <a:latin typeface="Segoe UI" pitchFamily="34" charset="0"/>
                 <a:ea typeface="Segoe UI" pitchFamily="34" charset="-122"/>
@@ -9848,7 +9850,7 @@
               </a:rPr>
               <a:t>If the memory is muddy, every agent is confidently wrong in its own unique direction.</a:t>
             </a:r>
-            <a:endParaRPr lang="en-US" sz="1150" dirty="0"/>
+            <a:endParaRPr lang="en-US" sz="1800" dirty="0"/>
           </a:p>
         </p:txBody>
       </p:sp>
@@ -9860,8 +9862,8 @@
         </p:nvSpPr>
         <p:spPr>
           <a:xfrm>
-            <a:off x="10698480" y="6382512"/>
-            <a:ext cx="1188720" cy="365760"/>
+            <a:off x="10698480" y="6309360"/>
+            <a:ext cx="1188720" cy="411480"/>
           </a:xfrm>
           <a:prstGeom prst="rect">
             <a:avLst/>
@@ -9877,9 +9879,9 @@
               <a:buNone/>
             </a:pPr>
             <a:r>
-              <a:rPr lang="en-US" sz="1000" dirty="0">
-                <a:solidFill>
-                  <a:srgbClr val="64748B"/>
+              <a:rPr lang="en-US" sz="1800" dirty="0">
+                <a:solidFill>
+                  <a:srgbClr val="8FA3BF"/>
                 </a:solidFill>
                 <a:latin typeface="Consolas" pitchFamily="34" charset="0"/>
                 <a:ea typeface="Consolas" pitchFamily="34" charset="-122"/>
@@ -9887,7 +9889,7 @@
               </a:rPr>
               <a:t>6 / 14</a:t>
             </a:r>
-            <a:endParaRPr lang="en-US" sz="1000" dirty="0"/>
+            <a:endParaRPr lang="en-US" sz="1800" dirty="0"/>
           </a:p>
         </p:txBody>
       </p:sp>
@@ -9971,8 +9973,8 @@
         </p:nvSpPr>
         <p:spPr>
           <a:xfrm>
-            <a:off x="822960" y="502920"/>
-            <a:ext cx="10515600" cy="365760"/>
+            <a:off x="822960" y="457200"/>
+            <a:ext cx="10515600" cy="411480"/>
           </a:xfrm>
           <a:prstGeom prst="rect">
             <a:avLst/>
@@ -9988,7 +9990,7 @@
               <a:buNone/>
             </a:pPr>
             <a:r>
-              <a:rPr lang="en-US" sz="1200" spc="300" kern="0" dirty="0">
+              <a:rPr lang="en-US" sz="1800" spc="300" kern="0" dirty="0">
                 <a:solidFill>
                   <a:srgbClr val="06B6D4"/>
                 </a:solidFill>
@@ -9998,7 +10000,7 @@
               </a:rPr>
               <a:t>COMPANY MEMORY</a:t>
             </a:r>
-            <a:endParaRPr lang="en-US" sz="1200" dirty="0"/>
+            <a:endParaRPr lang="en-US" sz="1800" dirty="0"/>
           </a:p>
         </p:txBody>
       </p:sp>
@@ -10048,8 +10050,8 @@
           <p:nvPr/>
         </p:nvGraphicFramePr>
         <p:xfrm>
-          <a:off x="822960" y="1874520"/>
-          <a:ext cx="10515600" cy="3337560"/>
+          <a:off x="822960" y="1783080"/>
+          <a:ext cx="10515600" cy="3383280"/>
         </p:xfrm>
         <a:graphic xmlns:a="http://schemas.openxmlformats.org/drawingml/2006/main">
           <a:graphicData uri="http://schemas.openxmlformats.org/drawingml/2006/chart">
@@ -10065,7 +10067,7 @@
         </p:nvSpPr>
         <p:spPr>
           <a:xfrm>
-            <a:off x="822960" y="5413248"/>
+            <a:off x="822960" y="5321808"/>
             <a:ext cx="10515600" cy="0"/>
           </a:xfrm>
           <a:prstGeom prst="line">
@@ -10088,8 +10090,8 @@
         </p:nvSpPr>
         <p:spPr>
           <a:xfrm>
-            <a:off x="822960" y="5504688"/>
-            <a:ext cx="10424160" cy="411480"/>
+            <a:off x="822960" y="5394960"/>
+            <a:ext cx="10424160" cy="502920"/>
           </a:xfrm>
           <a:prstGeom prst="rect">
             <a:avLst/>
@@ -10105,7 +10107,7 @@
               <a:buNone/>
             </a:pPr>
             <a:r>
-              <a:rPr lang="en-US" sz="1300" i="1" dirty="0">
+              <a:rPr lang="en-US" sz="1800" i="1" dirty="0">
                 <a:solidFill>
                   <a:srgbClr val="06B6D4"/>
                 </a:solidFill>
@@ -10115,7 +10117,7 @@
               </a:rPr>
               <a:t>→  Memory design is governance design: deciding what is a rule versus a status forces clarity.</a:t>
             </a:r>
-            <a:endParaRPr lang="en-US" sz="1300" dirty="0"/>
+            <a:endParaRPr lang="en-US" sz="1800" dirty="0"/>
           </a:p>
         </p:txBody>
       </p:sp>
@@ -10150,8 +10152,8 @@
         </p:nvSpPr>
         <p:spPr>
           <a:xfrm>
-            <a:off x="822960" y="6053328"/>
-            <a:ext cx="9692640" cy="457200"/>
+            <a:off x="822960" y="6035040"/>
+            <a:ext cx="10424160" cy="566928"/>
           </a:xfrm>
           <a:prstGeom prst="rect">
             <a:avLst/>
@@ -10167,9 +10169,9 @@
               <a:buNone/>
             </a:pPr>
             <a:r>
-              <a:rPr lang="en-US" sz="1150" dirty="0">
-                <a:solidFill>
-                  <a:srgbClr val="64748B"/>
+              <a:rPr lang="en-US" sz="1800" dirty="0">
+                <a:solidFill>
+                  <a:srgbClr val="8FA3BF"/>
                 </a:solidFill>
                 <a:latin typeface="Segoe UI" pitchFamily="34" charset="0"/>
                 <a:ea typeface="Segoe UI" pitchFamily="34" charset="-122"/>
@@ -10177,7 +10179,7 @@
               </a:rPr>
               <a:t>Illustrative composition; status is overwritten constantly while rules stay append-only.</a:t>
             </a:r>
-            <a:endParaRPr lang="en-US" sz="1150" dirty="0"/>
+            <a:endParaRPr lang="en-US" sz="1800" dirty="0"/>
           </a:p>
         </p:txBody>
       </p:sp>
@@ -10189,8 +10191,8 @@
         </p:nvSpPr>
         <p:spPr>
           <a:xfrm>
-            <a:off x="10698480" y="6382512"/>
-            <a:ext cx="1188720" cy="365760"/>
+            <a:off x="10698480" y="6309360"/>
+            <a:ext cx="1188720" cy="411480"/>
           </a:xfrm>
           <a:prstGeom prst="rect">
             <a:avLst/>
@@ -10206,9 +10208,9 @@
               <a:buNone/>
             </a:pPr>
             <a:r>
-              <a:rPr lang="en-US" sz="1000" dirty="0">
-                <a:solidFill>
-                  <a:srgbClr val="64748B"/>
+              <a:rPr lang="en-US" sz="1800" dirty="0">
+                <a:solidFill>
+                  <a:srgbClr val="8FA3BF"/>
                 </a:solidFill>
                 <a:latin typeface="Consolas" pitchFamily="34" charset="0"/>
                 <a:ea typeface="Consolas" pitchFamily="34" charset="-122"/>
@@ -10216,7 +10218,7 @@
               </a:rPr>
               <a:t>7 / 14</a:t>
             </a:r>
-            <a:endParaRPr lang="en-US" sz="1000" dirty="0"/>
+            <a:endParaRPr lang="en-US" sz="1800" dirty="0"/>
           </a:p>
         </p:txBody>
       </p:sp>
@@ -10300,8 +10302,8 @@
         </p:nvSpPr>
         <p:spPr>
           <a:xfrm>
-            <a:off x="822960" y="502920"/>
-            <a:ext cx="10515600" cy="365760"/>
+            <a:off x="822960" y="457200"/>
+            <a:ext cx="10515600" cy="411480"/>
           </a:xfrm>
           <a:prstGeom prst="rect">
             <a:avLst/>
@@ -10317,7 +10319,7 @@
               <a:buNone/>
             </a:pPr>
             <a:r>
-              <a:rPr lang="en-US" sz="1200" spc="300" kern="0" dirty="0">
+              <a:rPr lang="en-US" sz="1800" spc="300" kern="0" dirty="0">
                 <a:solidFill>
                   <a:srgbClr val="06B6D4"/>
                 </a:solidFill>
@@ -10327,7 +10329,7 @@
               </a:rPr>
               <a:t>PROTOCOL 3 &amp; 4</a:t>
             </a:r>
-            <a:endParaRPr lang="en-US" sz="1200" dirty="0"/>
+            <a:endParaRPr lang="en-US" sz="1800" dirty="0"/>
           </a:p>
         </p:txBody>
       </p:sp>
@@ -10378,12 +10380,12 @@
         </p:nvSpPr>
         <p:spPr>
           <a:xfrm>
-            <a:off x="822960" y="2011680"/>
-            <a:ext cx="5074920" cy="3611880"/>
+            <a:off x="822960" y="1965960"/>
+            <a:ext cx="5074920" cy="3657600"/>
           </a:xfrm>
           <a:prstGeom prst="roundRect">
             <a:avLst>
-              <a:gd name="adj" fmla="val 2025"/>
+              <a:gd name="adj" fmla="val 2000"/>
             </a:avLst>
           </a:prstGeom>
           <a:solidFill>
@@ -10405,8 +10407,8 @@
         </p:nvSpPr>
         <p:spPr>
           <a:xfrm>
-            <a:off x="1097280" y="2240280"/>
-            <a:ext cx="4526280" cy="502920"/>
+            <a:off x="1097280" y="2194560"/>
+            <a:ext cx="4526280" cy="548640"/>
           </a:xfrm>
           <a:prstGeom prst="rect">
             <a:avLst/>
@@ -10422,7 +10424,7 @@
               <a:buNone/>
             </a:pPr>
             <a:r>
-              <a:rPr lang="en-US" sz="1650" b="1" dirty="0">
+              <a:rPr lang="en-US" sz="2000" b="1" dirty="0">
                 <a:solidFill>
                   <a:srgbClr val="06B6D4"/>
                 </a:solidFill>
@@ -10432,7 +10434,7 @@
               </a:rPr>
               <a:t>Prompt-driven operations</a:t>
             </a:r>
-            <a:endParaRPr lang="en-US" sz="1650" dirty="0"/>
+            <a:endParaRPr lang="en-US" sz="2000" dirty="0"/>
           </a:p>
         </p:txBody>
       </p:sp>
@@ -10468,7 +10470,7 @@
               <a:buChar char="▸"/>
             </a:pPr>
             <a:r>
-              <a:rPr lang="en-US" sz="1280" dirty="0">
+              <a:rPr lang="en-US" sz="1800" dirty="0">
                 <a:solidFill>
                   <a:srgbClr val="CBD5E1"/>
                 </a:solidFill>
@@ -10478,7 +10480,7 @@
               </a:rPr>
               <a:t>Quality depends on phrasing and vibes</a:t>
             </a:r>
-            <a:endParaRPr lang="en-US" sz="1280" dirty="0"/>
+            <a:endParaRPr lang="en-US" sz="1800" dirty="0"/>
           </a:p>
           <a:p>
             <a:pPr marL="342900" indent="-342900">
@@ -10492,7 +10494,7 @@
               <a:buChar char="▸"/>
             </a:pPr>
             <a:r>
-              <a:rPr lang="en-US" sz="1280" dirty="0">
+              <a:rPr lang="en-US" sz="1800" dirty="0">
                 <a:solidFill>
                   <a:srgbClr val="CBD5E1"/>
                 </a:solidFill>
@@ -10502,7 +10504,7 @@
               </a:rPr>
               <a:t>Claims pass because a status field says done</a:t>
             </a:r>
-            <a:endParaRPr lang="en-US" sz="1280" dirty="0"/>
+            <a:endParaRPr lang="en-US" sz="1800" dirty="0"/>
           </a:p>
           <a:p>
             <a:pPr marL="342900" indent="-342900">
@@ -10516,7 +10518,7 @@
               <a:buChar char="▸"/>
             </a:pPr>
             <a:r>
-              <a:rPr lang="en-US" sz="1280" dirty="0">
+              <a:rPr lang="en-US" sz="1800" dirty="0">
                 <a:solidFill>
                   <a:srgbClr val="CBD5E1"/>
                 </a:solidFill>
@@ -10526,7 +10528,7 @@
               </a:rPr>
               <a:t>Failures get silently requeued and forgotten</a:t>
             </a:r>
-            <a:endParaRPr lang="en-US" sz="1280" dirty="0"/>
+            <a:endParaRPr lang="en-US" sz="1800" dirty="0"/>
           </a:p>
         </p:txBody>
       </p:sp>
@@ -10538,12 +10540,12 @@
         </p:nvSpPr>
         <p:spPr>
           <a:xfrm>
-            <a:off x="6291072" y="2011680"/>
-            <a:ext cx="5074920" cy="3611880"/>
+            <a:off x="6291072" y="1965960"/>
+            <a:ext cx="5074920" cy="3657600"/>
           </a:xfrm>
           <a:prstGeom prst="roundRect">
             <a:avLst>
-              <a:gd name="adj" fmla="val 2025"/>
+              <a:gd name="adj" fmla="val 2000"/>
             </a:avLst>
           </a:prstGeom>
           <a:solidFill>
@@ -10565,8 +10567,8 @@
         </p:nvSpPr>
         <p:spPr>
           <a:xfrm>
-            <a:off x="6565392" y="2240280"/>
-            <a:ext cx="4526280" cy="502920"/>
+            <a:off x="6565392" y="2194560"/>
+            <a:ext cx="4526280" cy="548640"/>
           </a:xfrm>
           <a:prstGeom prst="rect">
             <a:avLst/>
@@ -10582,7 +10584,7 @@
               <a:buNone/>
             </a:pPr>
             <a:r>
-              <a:rPr lang="en-US" sz="1650" b="1" dirty="0">
+              <a:rPr lang="en-US" sz="2000" b="1" dirty="0">
                 <a:solidFill>
                   <a:srgbClr val="93C5FD"/>
                 </a:solidFill>
@@ -10592,7 +10594,7 @@
               </a:rPr>
               <a:t>Protocol-driven operations</a:t>
             </a:r>
-            <a:endParaRPr lang="en-US" sz="1650" dirty="0"/>
+            <a:endParaRPr lang="en-US" sz="2000" dirty="0"/>
           </a:p>
         </p:txBody>
       </p:sp>
@@ -10628,7 +10630,7 @@
               <a:buChar char="▸"/>
             </a:pPr>
             <a:r>
-              <a:rPr lang="en-US" sz="1280" dirty="0">
+              <a:rPr lang="en-US" sz="1800" dirty="0">
                 <a:solidFill>
                   <a:srgbClr val="CBD5E1"/>
                 </a:solidFill>
@@ -10638,7 +10640,7 @@
               </a:rPr>
               <a:t>Rooms over whispers: coordination is visible and auditable</a:t>
             </a:r>
-            <a:endParaRPr lang="en-US" sz="1280" dirty="0"/>
+            <a:endParaRPr lang="en-US" sz="1800" dirty="0"/>
           </a:p>
           <a:p>
             <a:pPr marL="342900" indent="-342900">
@@ -10652,7 +10654,7 @@
               <a:buChar char="▸"/>
             </a:pPr>
             <a:r>
-              <a:rPr lang="en-US" sz="1280" dirty="0">
+              <a:rPr lang="en-US" sz="1800" dirty="0">
                 <a:solidFill>
                   <a:srgbClr val="CBD5E1"/>
                 </a:solidFill>
@@ -10662,7 +10664,7 @@
               </a:rPr>
               <a:t>Queues over interrupts: pause, resume, and skip are explicit</a:t>
             </a:r>
-            <a:endParaRPr lang="en-US" sz="1280" dirty="0"/>
+            <a:endParaRPr lang="en-US" sz="1800" dirty="0"/>
           </a:p>
           <a:p>
             <a:pPr marL="342900" indent="-342900">
@@ -10676,7 +10678,7 @@
               <a:buChar char="▸"/>
             </a:pPr>
             <a:r>
-              <a:rPr lang="en-US" sz="1280" dirty="0">
+              <a:rPr lang="en-US" sz="1800" dirty="0">
                 <a:solidFill>
                   <a:srgbClr val="CBD5E1"/>
                 </a:solidFill>
@@ -10686,7 +10688,7 @@
               </a:rPr>
               <a:t>A protocol gap becomes a written amendment everyone inherits</a:t>
             </a:r>
-            <a:endParaRPr lang="en-US" sz="1280" dirty="0"/>
+            <a:endParaRPr lang="en-US" sz="1800" dirty="0"/>
           </a:p>
         </p:txBody>
       </p:sp>
@@ -10721,8 +10723,8 @@
         </p:nvSpPr>
         <p:spPr>
           <a:xfrm>
-            <a:off x="822960" y="6053328"/>
-            <a:ext cx="9692640" cy="457200"/>
+            <a:off x="822960" y="6035040"/>
+            <a:ext cx="10424160" cy="566928"/>
           </a:xfrm>
           <a:prstGeom prst="rect">
             <a:avLst/>
@@ -10738,9 +10740,9 @@
               <a:buNone/>
             </a:pPr>
             <a:r>
-              <a:rPr lang="en-US" sz="1150" dirty="0">
-                <a:solidFill>
-                  <a:srgbClr val="64748B"/>
+              <a:rPr lang="en-US" sz="1800" dirty="0">
+                <a:solidFill>
+                  <a:srgbClr val="8FA3BF"/>
                 </a:solidFill>
                 <a:latin typeface="Segoe UI" pitchFamily="34" charset="0"/>
                 <a:ea typeface="Segoe UI" pitchFamily="34" charset="-122"/>
@@ -10748,7 +10750,7 @@
               </a:rPr>
               <a:t>Demote prompts to suggestions and write the rules down - the workforce gets smarter.</a:t>
             </a:r>
-            <a:endParaRPr lang="en-US" sz="1150" dirty="0"/>
+            <a:endParaRPr lang="en-US" sz="1800" dirty="0"/>
           </a:p>
         </p:txBody>
       </p:sp>
@@ -10760,8 +10762,8 @@
         </p:nvSpPr>
         <p:spPr>
           <a:xfrm>
-            <a:off x="10698480" y="6382512"/>
-            <a:ext cx="1188720" cy="365760"/>
+            <a:off x="10698480" y="6309360"/>
+            <a:ext cx="1188720" cy="411480"/>
           </a:xfrm>
           <a:prstGeom prst="rect">
             <a:avLst/>
@@ -10777,9 +10779,9 @@
               <a:buNone/>
             </a:pPr>
             <a:r>
-              <a:rPr lang="en-US" sz="1000" dirty="0">
-                <a:solidFill>
-                  <a:srgbClr val="64748B"/>
+              <a:rPr lang="en-US" sz="1800" dirty="0">
+                <a:solidFill>
+                  <a:srgbClr val="8FA3BF"/>
                 </a:solidFill>
                 <a:latin typeface="Consolas" pitchFamily="34" charset="0"/>
                 <a:ea typeface="Consolas" pitchFamily="34" charset="-122"/>
@@ -10787,7 +10789,7 @@
               </a:rPr>
               <a:t>8 / 14</a:t>
             </a:r>
-            <a:endParaRPr lang="en-US" sz="1000" dirty="0"/>
+            <a:endParaRPr lang="en-US" sz="1800" dirty="0"/>
           </a:p>
         </p:txBody>
       </p:sp>
@@ -10871,8 +10873,8 @@
         </p:nvSpPr>
         <p:spPr>
           <a:xfrm>
-            <a:off x="822960" y="502920"/>
-            <a:ext cx="10515600" cy="365760"/>
+            <a:off x="822960" y="457200"/>
+            <a:ext cx="10515600" cy="411480"/>
           </a:xfrm>
           <a:prstGeom prst="rect">
             <a:avLst/>
@@ -10888,7 +10890,7 @@
               <a:buNone/>
             </a:pPr>
             <a:r>
-              <a:rPr lang="en-US" sz="1200" spc="300" kern="0" dirty="0">
+              <a:rPr lang="en-US" sz="1800" spc="300" kern="0" dirty="0">
                 <a:solidFill>
                   <a:srgbClr val="06B6D4"/>
                 </a:solidFill>
@@ -10898,7 +10900,7 @@
               </a:rPr>
               <a:t>THE NUMBERS</a:t>
             </a:r>
-            <a:endParaRPr lang="en-US" sz="1200" dirty="0"/>
+            <a:endParaRPr lang="en-US" sz="1800" dirty="0"/>
           </a:p>
         </p:txBody>
       </p:sp>
@@ -10949,8 +10951,8 @@
         </p:nvSpPr>
         <p:spPr>
           <a:xfrm>
-            <a:off x="822960" y="2194560"/>
-            <a:ext cx="2423160" cy="2697480"/>
+            <a:off x="822960" y="1965960"/>
+            <a:ext cx="2423160" cy="3154680"/>
           </a:xfrm>
           <a:prstGeom prst="roundRect">
             <a:avLst>
@@ -10976,7 +10978,7 @@
         </p:nvSpPr>
         <p:spPr>
           <a:xfrm>
-            <a:off x="960120" y="2514600"/>
+            <a:off x="960120" y="2194560"/>
             <a:ext cx="2148840" cy="914400"/>
           </a:xfrm>
           <a:prstGeom prst="rect">
@@ -11015,8 +11017,8 @@
         </p:nvSpPr>
         <p:spPr>
           <a:xfrm>
-            <a:off x="960120" y="3520440"/>
-            <a:ext cx="2148840" cy="502920"/>
+            <a:off x="960120" y="3200400"/>
+            <a:ext cx="2148840" cy="868680"/>
           </a:xfrm>
           <a:prstGeom prst="rect">
             <a:avLst/>
@@ -11032,7 +11034,7 @@
               <a:buNone/>
             </a:pPr>
             <a:r>
-              <a:rPr lang="en-US" sz="1450" b="1" dirty="0">
+              <a:rPr lang="en-US" sz="1800" b="1" dirty="0">
                 <a:solidFill>
                   <a:srgbClr val="FFFFFF"/>
                 </a:solidFill>
@@ -11042,7 +11044,7 @@
               </a:rPr>
               <a:t>Specialist agents</a:t>
             </a:r>
-            <a:endParaRPr lang="en-US" sz="1450" dirty="0"/>
+            <a:endParaRPr lang="en-US" sz="1800" dirty="0"/>
           </a:p>
         </p:txBody>
       </p:sp>
@@ -11054,8 +11056,8 @@
         </p:nvSpPr>
         <p:spPr>
           <a:xfrm>
-            <a:off x="1005840" y="4069080"/>
-            <a:ext cx="2057400" cy="685800"/>
+            <a:off x="1005840" y="4114800"/>
+            <a:ext cx="2057400" cy="914400"/>
           </a:xfrm>
           <a:prstGeom prst="rect">
             <a:avLst/>
@@ -11071,7 +11073,7 @@
               <a:buNone/>
             </a:pPr>
             <a:r>
-              <a:rPr lang="en-US" sz="1050" dirty="0">
+              <a:rPr lang="en-US" sz="1800" dirty="0">
                 <a:solidFill>
                   <a:srgbClr val="94A3B8"/>
                 </a:solidFill>
@@ -11081,7 +11083,7 @@
               </a:rPr>
               <a:t>Coordinated through shared rooms and per-agent queues</a:t>
             </a:r>
-            <a:endParaRPr lang="en-US" sz="1050" dirty="0"/>
+            <a:endParaRPr lang="en-US" sz="1800" dirty="0"/>
           </a:p>
         </p:txBody>
       </p:sp>
@@ -11093,8 +11095,8 @@
         </p:nvSpPr>
         <p:spPr>
           <a:xfrm>
-            <a:off x="3520440" y="2194560"/>
-            <a:ext cx="2423160" cy="2697480"/>
+            <a:off x="3520440" y="1965960"/>
+            <a:ext cx="2423160" cy="3154680"/>
           </a:xfrm>
           <a:prstGeom prst="roundRect">
             <a:avLst>
@@ -11120,7 +11122,7 @@
         </p:nvSpPr>
         <p:spPr>
           <a:xfrm>
-            <a:off x="3657600" y="2514600"/>
+            <a:off x="3657600" y="2194560"/>
             <a:ext cx="2148840" cy="914400"/>
           </a:xfrm>
           <a:prstGeom prst="rect">
@@ -11159,8 +11161,8 @@
         </p:nvSpPr>
         <p:spPr>
           <a:xfrm>
-            <a:off x="3657600" y="3520440"/>
-            <a:ext cx="2148840" cy="502920"/>
+            <a:off x="3657600" y="3200400"/>
+            <a:ext cx="2148840" cy="868680"/>
           </a:xfrm>
           <a:prstGeom prst="rect">
             <a:avLst/>
@@ -11176,7 +11178,7 @@
               <a:buNone/>
             </a:pPr>
             <a:r>
-              <a:rPr lang="en-US" sz="1450" b="1" dirty="0">
+              <a:rPr lang="en-US" sz="1800" b="1" dirty="0">
                 <a:solidFill>
                   <a:srgbClr val="FFFFFF"/>
                 </a:solidFill>
@@ -11186,7 +11188,7 @@
               </a:rPr>
               <a:t>Router accuracy</a:t>
             </a:r>
-            <a:endParaRPr lang="en-US" sz="1450" dirty="0"/>
+            <a:endParaRPr lang="en-US" sz="1800" dirty="0"/>
           </a:p>
         </p:txBody>
       </p:sp>
@@ -11198,8 +11200,8 @@
         </p:nvSpPr>
         <p:spPr>
           <a:xfrm>
-            <a:off x="3703320" y="4069080"/>
-            <a:ext cx="2057400" cy="685800"/>
+            <a:off x="3703320" y="4114800"/>
+            <a:ext cx="2057400" cy="914400"/>
           </a:xfrm>
           <a:prstGeom prst="rect">
             <a:avLst/>
@@ -11215,7 +11217,7 @@
               <a:buNone/>
             </a:pPr>
             <a:r>
-              <a:rPr lang="en-US" sz="1050" dirty="0">
+              <a:rPr lang="en-US" sz="1800" dirty="0">
                 <a:solidFill>
                   <a:srgbClr val="94A3B8"/>
                 </a:solidFill>
@@ -11225,7 +11227,7 @@
               </a:rPr>
               <a:t>On the 30-query validation set that gates every change</a:t>
             </a:r>
-            <a:endParaRPr lang="en-US" sz="1050" dirty="0"/>
+            <a:endParaRPr lang="en-US" sz="1800" dirty="0"/>
           </a:p>
         </p:txBody>
       </p:sp>
@@ -11237,8 +11239,8 @@
         </p:nvSpPr>
         <p:spPr>
           <a:xfrm>
-            <a:off x="6217920" y="2194560"/>
-            <a:ext cx="2423160" cy="2697480"/>
+            <a:off x="6217920" y="1965960"/>
+            <a:ext cx="2423160" cy="3154680"/>
           </a:xfrm>
           <a:prstGeom prst="roundRect">
             <a:avLst>
@@ -11264,7 +11266,7 @@
         </p:nvSpPr>
         <p:spPr>
           <a:xfrm>
-            <a:off x="6355080" y="2514600"/>
+            <a:off x="6355080" y="2194560"/>
             <a:ext cx="2148840" cy="914400"/>
           </a:xfrm>
           <a:prstGeom prst="rect">
@@ -11303,8 +11305,8 @@
         </p:nvSpPr>
         <p:spPr>
           <a:xfrm>
-            <a:off x="6355080" y="3520440"/>
-            <a:ext cx="2148840" cy="502920"/>
+            <a:off x="6355080" y="3200400"/>
+            <a:ext cx="2148840" cy="868680"/>
           </a:xfrm>
           <a:prstGeom prst="rect">
             <a:avLst/>
@@ -11320,7 +11322,7 @@
               <a:buNone/>
             </a:pPr>
             <a:r>
-              <a:rPr lang="en-US" sz="1450" b="1" dirty="0">
+              <a:rPr lang="en-US" sz="1800" b="1" dirty="0">
                 <a:solidFill>
                   <a:srgbClr val="FFFFFF"/>
                 </a:solidFill>
@@ -11330,7 +11332,7 @@
               </a:rPr>
               <a:t>Production checks</a:t>
             </a:r>
-            <a:endParaRPr lang="en-US" sz="1450" dirty="0"/>
+            <a:endParaRPr lang="en-US" sz="1800" dirty="0"/>
           </a:p>
         </p:txBody>
       </p:sp>
@@ -11342,8 +11344,8 @@
         </p:nvSpPr>
         <p:spPr>
           <a:xfrm>
-            <a:off x="6400800" y="4069080"/>
-            <a:ext cx="2057400" cy="685800"/>
+            <a:off x="6400800" y="4114800"/>
+            <a:ext cx="2057400" cy="914400"/>
           </a:xfrm>
           <a:prstGeom prst="rect">
             <a:avLst/>
@@ -11359,7 +11361,7 @@
               <a:buNone/>
             </a:pPr>
             <a:r>
-              <a:rPr lang="en-US" sz="1050" dirty="0">
+              <a:rPr lang="en-US" sz="1800" dirty="0">
                 <a:solidFill>
                   <a:srgbClr val="94A3B8"/>
                 </a:solidFill>
@@ -11369,7 +11371,7 @@
               </a:rPr>
               <a:t>One miss, one sharpened boundary, full re-run</a:t>
             </a:r>
-            <a:endParaRPr lang="en-US" sz="1050" dirty="0"/>
+            <a:endParaRPr lang="en-US" sz="1800" dirty="0"/>
           </a:p>
         </p:txBody>
       </p:sp>
@@ -11381,8 +11383,8 @@
         </p:nvSpPr>
         <p:spPr>
           <a:xfrm>
-            <a:off x="8915400" y="2194560"/>
-            <a:ext cx="2423160" cy="2697480"/>
+            <a:off x="8915400" y="1965960"/>
+            <a:ext cx="2423160" cy="3154680"/>
           </a:xfrm>
           <a:prstGeom prst="roundRect">
             <a:avLst>
@@ -11408,7 +11410,7 @@
         </p:nvSpPr>
         <p:spPr>
           <a:xfrm>
-            <a:off x="9052560" y="2514600"/>
+            <a:off x="9052560" y="2194560"/>
             <a:ext cx="2148840" cy="914400"/>
           </a:xfrm>
           <a:prstGeom prst="rect">
@@ -11447,8 +11449,8 @@
         </p:nvSpPr>
         <p:spPr>
           <a:xfrm>
-            <a:off x="9052560" y="3520440"/>
-            <a:ext cx="2148840" cy="502920"/>
+            <a:off x="9052560" y="3200400"/>
+            <a:ext cx="2148840" cy="868680"/>
           </a:xfrm>
           <a:prstGeom prst="rect">
             <a:avLst/>
@@ -11464,7 +11466,7 @@
               <a:buNone/>
             </a:pPr>
             <a:r>
-              <a:rPr lang="en-US" sz="1450" b="1" dirty="0">
+              <a:rPr lang="en-US" sz="1800" b="1" dirty="0">
                 <a:solidFill>
                   <a:srgbClr val="FFFFFF"/>
                 </a:solidFill>
@@ -11474,7 +11476,7 @@
               </a:rPr>
               <a:t>Self-approved releases</a:t>
             </a:r>
-            <a:endParaRPr lang="en-US" sz="1450" dirty="0"/>
+            <a:endParaRPr lang="en-US" sz="1800" dirty="0"/>
           </a:p>
         </p:txBody>
       </p:sp>
@@ -11486,8 +11488,8 @@
         </p:nvSpPr>
         <p:spPr>
           <a:xfrm>
-            <a:off x="9098280" y="4069080"/>
-            <a:ext cx="2057400" cy="685800"/>
+            <a:off x="9098280" y="4114800"/>
+            <a:ext cx="2057400" cy="914400"/>
           </a:xfrm>
           <a:prstGeom prst="rect">
             <a:avLst/>
@@ -11503,7 +11505,7 @@
               <a:buNone/>
             </a:pPr>
             <a:r>
-              <a:rPr lang="en-US" sz="1050" dirty="0">
+              <a:rPr lang="en-US" sz="1800" dirty="0">
                 <a:solidFill>
                   <a:srgbClr val="94A3B8"/>
                 </a:solidFill>
@@ -11513,7 +11515,7 @@
               </a:rPr>
               <a:t>Agents never approve their own work - the human signs off</a:t>
             </a:r>
-            <a:endParaRPr lang="en-US" sz="1050" dirty="0"/>
+            <a:endParaRPr lang="en-US" sz="1800" dirty="0"/>
           </a:p>
         </p:txBody>
       </p:sp>
@@ -11525,7 +11527,7 @@
         </p:nvSpPr>
         <p:spPr>
           <a:xfrm>
-            <a:off x="822960" y="5413248"/>
+            <a:off x="822960" y="5321808"/>
             <a:ext cx="10515600" cy="0"/>
           </a:xfrm>
           <a:prstGeom prst="line">
@@ -11548,8 +11550,8 @@
         </p:nvSpPr>
         <p:spPr>
           <a:xfrm>
-            <a:off x="822960" y="5504688"/>
-            <a:ext cx="10424160" cy="411480"/>
+            <a:off x="822960" y="5394960"/>
+            <a:ext cx="10424160" cy="502920"/>
           </a:xfrm>
           <a:prstGeom prst="rect">
             <a:avLst/>
@@ -11565,7 +11567,7 @@
               <a:buNone/>
             </a:pPr>
             <a:r>
-              <a:rPr lang="en-US" sz="1300" i="1" dirty="0">
+              <a:rPr lang="en-US" sz="1800" i="1" dirty="0">
                 <a:solidFill>
                   <a:srgbClr val="06B6D4"/>
                 </a:solidFill>
@@ -11575,7 +11577,7 @@
               </a:rPr>
               <a:t>→  Honest evidence is the whole system: nothing here is claimed, everything is recorded.</a:t>
             </a:r>
-            <a:endParaRPr lang="en-US" sz="1300" dirty="0"/>
+            <a:endParaRPr lang="en-US" sz="1800" dirty="0"/>
           </a:p>
         </p:txBody>
       </p:sp>
@@ -11587,8 +11589,8 @@
         </p:nvSpPr>
         <p:spPr>
           <a:xfrm>
-            <a:off x="10698480" y="6382512"/>
-            <a:ext cx="1188720" cy="365760"/>
+            <a:off x="10698480" y="6309360"/>
+            <a:ext cx="1188720" cy="411480"/>
           </a:xfrm>
           <a:prstGeom prst="rect">
             <a:avLst/>
@@ -11604,9 +11606,9 @@
               <a:buNone/>
             </a:pPr>
             <a:r>
-              <a:rPr lang="en-US" sz="1000" dirty="0">
-                <a:solidFill>
-                  <a:srgbClr val="64748B"/>
+              <a:rPr lang="en-US" sz="1800" dirty="0">
+                <a:solidFill>
+                  <a:srgbClr val="8FA3BF"/>
                 </a:solidFill>
                 <a:latin typeface="Consolas" pitchFamily="34" charset="0"/>
                 <a:ea typeface="Consolas" pitchFamily="34" charset="-122"/>
@@ -11614,7 +11616,7 @@
               </a:rPr>
               <a:t>9 / 14</a:t>
             </a:r>
-            <a:endParaRPr lang="en-US" sz="1000" dirty="0"/>
+            <a:endParaRPr lang="en-US" sz="1800" dirty="0"/>
           </a:p>
         </p:txBody>
       </p:sp>

</xml_diff>